<commit_message>
Update for ollama layer
</commit_message>
<xml_diff>
--- a/architecture/Project Presentation v1.pptx
+++ b/architecture/Project Presentation v1.pptx
@@ -395,7 +395,7 @@
             <a:pPr indent="0" algn="r">
               <a:buNone/>
             </a:pPr>
-            <a:fld id="{C4610FBB-4024-4889-BB1D-63042E03A704}" type="slidenum">
+            <a:fld id="{1CA4270F-5878-4619-B90F-55897B9D01E2}" type="slidenum">
               <a:rPr lang="en-AU" sz="1400" b="0" u="none" strike="noStrike">
                 <a:solidFill>
                   <a:srgbClr val="000000"/>
@@ -453,7 +453,7 @@
         <p:spPr>
           <a:xfrm>
             <a:off x="216360" y="812520"/>
-            <a:ext cx="7123680" cy="4005720"/>
+            <a:ext cx="7123320" cy="4005360"/>
           </a:xfrm>
           <a:prstGeom prst="rect">
             <a:avLst/>
@@ -476,7 +476,7 @@
         <p:spPr>
           <a:xfrm>
             <a:off x="756000" y="5078520"/>
-            <a:ext cx="6044400" cy="4807800"/>
+            <a:ext cx="6044040" cy="4807440"/>
           </a:xfrm>
           <a:prstGeom prst="rect">
             <a:avLst/>
@@ -704,7 +704,7 @@
         <p:spPr>
           <a:xfrm>
             <a:off x="216000" y="812520"/>
-            <a:ext cx="7125480" cy="4007520"/>
+            <a:ext cx="7125120" cy="4007160"/>
           </a:xfrm>
           <a:prstGeom prst="rect">
             <a:avLst/>
@@ -727,7 +727,7 @@
         <p:spPr>
           <a:xfrm>
             <a:off x="756000" y="5078520"/>
-            <a:ext cx="6046200" cy="4809600"/>
+            <a:ext cx="6045840" cy="4809240"/>
           </a:xfrm>
           <a:prstGeom prst="rect">
             <a:avLst/>
@@ -951,7 +951,7 @@
         <p:spPr>
           <a:xfrm>
             <a:off x="216000" y="812520"/>
-            <a:ext cx="7125480" cy="4007520"/>
+            <a:ext cx="7125120" cy="4007160"/>
           </a:xfrm>
           <a:prstGeom prst="rect">
             <a:avLst/>
@@ -974,7 +974,7 @@
         <p:spPr>
           <a:xfrm>
             <a:off x="756000" y="5078520"/>
-            <a:ext cx="6046200" cy="4809600"/>
+            <a:ext cx="6045840" cy="4809240"/>
           </a:xfrm>
           <a:prstGeom prst="rect">
             <a:avLst/>
@@ -1198,7 +1198,7 @@
         <p:spPr>
           <a:xfrm>
             <a:off x="216000" y="812520"/>
-            <a:ext cx="7125480" cy="4007520"/>
+            <a:ext cx="7125120" cy="4007160"/>
           </a:xfrm>
           <a:prstGeom prst="rect">
             <a:avLst/>
@@ -1221,7 +1221,7 @@
         <p:spPr>
           <a:xfrm>
             <a:off x="756000" y="5078520"/>
-            <a:ext cx="6046200" cy="4809600"/>
+            <a:ext cx="6045840" cy="4809240"/>
           </a:xfrm>
           <a:prstGeom prst="rect">
             <a:avLst/>
@@ -1468,7 +1468,7 @@
         <p:spPr>
           <a:xfrm>
             <a:off x="216000" y="812520"/>
-            <a:ext cx="7125480" cy="4007520"/>
+            <a:ext cx="7125120" cy="4007160"/>
           </a:xfrm>
           <a:prstGeom prst="rect">
             <a:avLst/>
@@ -1491,7 +1491,7 @@
         <p:spPr>
           <a:xfrm>
             <a:off x="756000" y="5078520"/>
-            <a:ext cx="6046200" cy="4809600"/>
+            <a:ext cx="6045840" cy="4809240"/>
           </a:xfrm>
           <a:prstGeom prst="rect">
             <a:avLst/>
@@ -1621,7 +1621,7 @@
         <p:spPr>
           <a:xfrm>
             <a:off x="216000" y="812520"/>
-            <a:ext cx="7125480" cy="4007520"/>
+            <a:ext cx="7125120" cy="4007160"/>
           </a:xfrm>
           <a:prstGeom prst="rect">
             <a:avLst/>
@@ -1644,7 +1644,7 @@
         <p:spPr>
           <a:xfrm>
             <a:off x="756000" y="5078520"/>
-            <a:ext cx="6046200" cy="4809600"/>
+            <a:ext cx="6045840" cy="4809240"/>
           </a:xfrm>
           <a:prstGeom prst="rect">
             <a:avLst/>
@@ -1951,7 +1951,7 @@
         <p:spPr>
           <a:xfrm>
             <a:off x="216000" y="812520"/>
-            <a:ext cx="7124040" cy="4005720"/>
+            <a:ext cx="7123680" cy="4005360"/>
           </a:xfrm>
           <a:prstGeom prst="rect">
             <a:avLst/>
@@ -1974,7 +1974,7 @@
         <p:spPr>
           <a:xfrm>
             <a:off x="756000" y="5078520"/>
-            <a:ext cx="6044400" cy="4807800"/>
+            <a:ext cx="6044040" cy="4807440"/>
           </a:xfrm>
           <a:prstGeom prst="rect">
             <a:avLst/>
@@ -2251,7 +2251,7 @@
         <p:spPr>
           <a:xfrm>
             <a:off x="216000" y="812520"/>
-            <a:ext cx="7125480" cy="4007520"/>
+            <a:ext cx="7125120" cy="4007160"/>
           </a:xfrm>
           <a:prstGeom prst="rect">
             <a:avLst/>
@@ -2274,7 +2274,7 @@
         <p:spPr>
           <a:xfrm>
             <a:off x="756000" y="5078520"/>
-            <a:ext cx="6046200" cy="4809600"/>
+            <a:ext cx="6045840" cy="4809240"/>
           </a:xfrm>
           <a:prstGeom prst="rect">
             <a:avLst/>
@@ -2357,7 +2357,7 @@
                 <a:latin typeface="Arial"/>
                 <a:ea typeface="Microsoft YaHei"/>
               </a:rPr>
-              <a:t>Gemini model was hosted in Google cloud</a:t>
+              <a:t>Cloud hosting provided by Ollama Cloud and Google Cloud</a:t>
             </a:r>
             <a:endParaRPr lang="en-AU" sz="2000" b="0" u="none" strike="noStrike">
               <a:solidFill>
@@ -2407,57 +2407,7 @@
                 <a:latin typeface="Arial"/>
                 <a:ea typeface="Microsoft YaHei"/>
               </a:rPr>
-              <a:t>Gpt-oss models outperformed Llama 3.3</a:t>
-            </a:r>
-            <a:endParaRPr lang="en-AU" sz="2000" b="0" u="none" strike="noStrike">
-              <a:solidFill>
-                <a:srgbClr val="000000"/>
-              </a:solidFill>
-              <a:effectLst/>
-              <a:uFillTx/>
-              <a:latin typeface="Arial"/>
-            </a:endParaRPr>
-          </a:p>
-          <a:p>
-            <a:pPr indent="0">
-              <a:lnSpc>
-                <a:spcPct val="100000"/>
-              </a:lnSpc>
-              <a:buNone/>
-              <a:tabLst>
-                <a:tab algn="l" pos="0"/>
-              </a:tabLst>
-            </a:pPr>
-            <a:endParaRPr lang="en-AU" sz="2000" b="0" u="none" strike="noStrike">
-              <a:solidFill>
-                <a:srgbClr val="000000"/>
-              </a:solidFill>
-              <a:effectLst/>
-              <a:uFillTx/>
-              <a:latin typeface="Arial"/>
-            </a:endParaRPr>
-          </a:p>
-          <a:p>
-            <a:pPr indent="0">
-              <a:lnSpc>
-                <a:spcPct val="100000"/>
-              </a:lnSpc>
-              <a:buNone/>
-              <a:tabLst>
-                <a:tab algn="l" pos="0"/>
-              </a:tabLst>
-            </a:pPr>
-            <a:r>
-              <a:rPr lang="en-AU" sz="2000" b="0" u="none" strike="noStrike">
-                <a:solidFill>
-                  <a:srgbClr val="000000"/>
-                </a:solidFill>
-                <a:effectLst/>
-                <a:uFillTx/>
-                <a:latin typeface="Arial"/>
-                <a:ea typeface="Microsoft YaHei"/>
-              </a:rPr>
-              <a:t>Google cloud outperformed local host</a:t>
+              <a:t>Cloud models outperformed local host</a:t>
             </a:r>
             <a:endParaRPr lang="en-AU" sz="2000" b="0" u="none" strike="noStrike">
               <a:solidFill>
@@ -2729,7 +2679,7 @@
         <p:spPr>
           <a:xfrm>
             <a:off x="216000" y="812520"/>
-            <a:ext cx="7124040" cy="4005720"/>
+            <a:ext cx="7123680" cy="4005360"/>
           </a:xfrm>
           <a:prstGeom prst="rect">
             <a:avLst/>
@@ -2752,7 +2702,7 @@
         <p:spPr>
           <a:xfrm>
             <a:off x="756000" y="5078520"/>
-            <a:ext cx="6044400" cy="4807800"/>
+            <a:ext cx="6044040" cy="4807440"/>
           </a:xfrm>
           <a:prstGeom prst="rect">
             <a:avLst/>
@@ -2950,7 +2900,7 @@
         <p:spPr>
           <a:xfrm>
             <a:off x="216000" y="812520"/>
-            <a:ext cx="7124040" cy="4005720"/>
+            <a:ext cx="7123680" cy="4005360"/>
           </a:xfrm>
           <a:prstGeom prst="rect">
             <a:avLst/>
@@ -2973,7 +2923,7 @@
         <p:spPr>
           <a:xfrm>
             <a:off x="756000" y="5078520"/>
-            <a:ext cx="6044400" cy="4807800"/>
+            <a:ext cx="6044040" cy="4807440"/>
           </a:xfrm>
           <a:prstGeom prst="rect">
             <a:avLst/>
@@ -3190,7 +3140,7 @@
         <p:spPr>
           <a:xfrm>
             <a:off x="216360" y="812520"/>
-            <a:ext cx="7123680" cy="4005720"/>
+            <a:ext cx="7123320" cy="4005360"/>
           </a:xfrm>
           <a:prstGeom prst="rect">
             <a:avLst/>
@@ -3213,7 +3163,7 @@
         <p:spPr>
           <a:xfrm>
             <a:off x="756000" y="5078520"/>
-            <a:ext cx="6044400" cy="4807800"/>
+            <a:ext cx="6044040" cy="4807440"/>
           </a:xfrm>
           <a:prstGeom prst="rect">
             <a:avLst/>
@@ -3528,7 +3478,7 @@
         <p:spPr>
           <a:xfrm>
             <a:off x="216000" y="812520"/>
-            <a:ext cx="7124040" cy="4005720"/>
+            <a:ext cx="7123680" cy="4005360"/>
           </a:xfrm>
           <a:prstGeom prst="rect">
             <a:avLst/>
@@ -3551,7 +3501,7 @@
         <p:spPr>
           <a:xfrm>
             <a:off x="756000" y="5078520"/>
-            <a:ext cx="6044400" cy="4807800"/>
+            <a:ext cx="6044040" cy="4807440"/>
           </a:xfrm>
           <a:prstGeom prst="rect">
             <a:avLst/>
@@ -3885,7 +3835,7 @@
         <p:spPr>
           <a:xfrm>
             <a:off x="216000" y="812520"/>
-            <a:ext cx="7124040" cy="4005720"/>
+            <a:ext cx="7123680" cy="4005360"/>
           </a:xfrm>
           <a:prstGeom prst="rect">
             <a:avLst/>
@@ -3908,7 +3858,7 @@
         <p:spPr>
           <a:xfrm>
             <a:off x="756000" y="5078520"/>
-            <a:ext cx="6044400" cy="4807800"/>
+            <a:ext cx="6044040" cy="4807440"/>
           </a:xfrm>
           <a:prstGeom prst="rect">
             <a:avLst/>
@@ -4144,7 +4094,7 @@
         <p:spPr>
           <a:xfrm>
             <a:off x="216000" y="812520"/>
-            <a:ext cx="7124040" cy="4005720"/>
+            <a:ext cx="7123680" cy="4005360"/>
           </a:xfrm>
           <a:prstGeom prst="rect">
             <a:avLst/>
@@ -4167,7 +4117,7 @@
         <p:spPr>
           <a:xfrm>
             <a:off x="756000" y="5078520"/>
-            <a:ext cx="6044400" cy="4807800"/>
+            <a:ext cx="6044040" cy="4807440"/>
           </a:xfrm>
           <a:prstGeom prst="rect">
             <a:avLst/>
@@ -4354,7 +4304,7 @@
         <p:spPr>
           <a:xfrm>
             <a:off x="216000" y="812520"/>
-            <a:ext cx="7124040" cy="4005720"/>
+            <a:ext cx="7123680" cy="4005360"/>
           </a:xfrm>
           <a:prstGeom prst="rect">
             <a:avLst/>
@@ -4377,7 +4327,7 @@
         <p:spPr>
           <a:xfrm>
             <a:off x="756000" y="5078520"/>
-            <a:ext cx="6044400" cy="4807800"/>
+            <a:ext cx="6044040" cy="4807440"/>
           </a:xfrm>
           <a:prstGeom prst="rect">
             <a:avLst/>
@@ -4670,7 +4620,7 @@
         <p:spPr>
           <a:xfrm>
             <a:off x="216000" y="812520"/>
-            <a:ext cx="7124040" cy="4005720"/>
+            <a:ext cx="7123680" cy="4005360"/>
           </a:xfrm>
           <a:prstGeom prst="rect">
             <a:avLst/>
@@ -4693,7 +4643,7 @@
         <p:spPr>
           <a:xfrm>
             <a:off x="756000" y="5078520"/>
-            <a:ext cx="6044400" cy="4807800"/>
+            <a:ext cx="6044040" cy="4807440"/>
           </a:xfrm>
           <a:prstGeom prst="rect">
             <a:avLst/>
@@ -4970,7 +4920,7 @@
         <p:spPr>
           <a:xfrm>
             <a:off x="216000" y="812520"/>
-            <a:ext cx="7124040" cy="4005720"/>
+            <a:ext cx="7123680" cy="4005360"/>
           </a:xfrm>
           <a:prstGeom prst="rect">
             <a:avLst/>
@@ -4993,7 +4943,7 @@
         <p:spPr>
           <a:xfrm>
             <a:off x="756000" y="5078520"/>
-            <a:ext cx="6044400" cy="4807800"/>
+            <a:ext cx="6044040" cy="4807440"/>
           </a:xfrm>
           <a:prstGeom prst="rect">
             <a:avLst/>
@@ -5365,7 +5315,7 @@
         <p:spPr>
           <a:xfrm>
             <a:off x="216000" y="812520"/>
-            <a:ext cx="7124040" cy="4005720"/>
+            <a:ext cx="7123680" cy="4005360"/>
           </a:xfrm>
           <a:prstGeom prst="rect">
             <a:avLst/>
@@ -5388,7 +5338,7 @@
         <p:spPr>
           <a:xfrm>
             <a:off x="756000" y="5078520"/>
-            <a:ext cx="6044400" cy="4807800"/>
+            <a:ext cx="6044040" cy="4807440"/>
           </a:xfrm>
           <a:prstGeom prst="rect">
             <a:avLst/>
@@ -5567,7 +5517,7 @@
         <p:spPr>
           <a:xfrm>
             <a:off x="216000" y="812520"/>
-            <a:ext cx="7124040" cy="4005720"/>
+            <a:ext cx="7123680" cy="4005360"/>
           </a:xfrm>
           <a:prstGeom prst="rect">
             <a:avLst/>
@@ -5590,7 +5540,7 @@
         <p:spPr>
           <a:xfrm>
             <a:off x="756000" y="5078520"/>
-            <a:ext cx="6044400" cy="4807800"/>
+            <a:ext cx="6044040" cy="4807440"/>
           </a:xfrm>
           <a:prstGeom prst="rect">
             <a:avLst/>
@@ -5720,7 +5670,7 @@
         <p:spPr>
           <a:xfrm>
             <a:off x="216360" y="812520"/>
-            <a:ext cx="7123680" cy="4005720"/>
+            <a:ext cx="7123320" cy="4005360"/>
           </a:xfrm>
           <a:prstGeom prst="rect">
             <a:avLst/>
@@ -5743,7 +5693,7 @@
         <p:spPr>
           <a:xfrm>
             <a:off x="756000" y="5078520"/>
-            <a:ext cx="6044400" cy="4807800"/>
+            <a:ext cx="6044040" cy="4807440"/>
           </a:xfrm>
           <a:prstGeom prst="rect">
             <a:avLst/>
@@ -5971,7 +5921,7 @@
         <p:spPr>
           <a:xfrm>
             <a:off x="216360" y="812520"/>
-            <a:ext cx="7123680" cy="4005720"/>
+            <a:ext cx="7123320" cy="4005360"/>
           </a:xfrm>
           <a:prstGeom prst="rect">
             <a:avLst/>
@@ -5994,7 +5944,7 @@
         <p:spPr>
           <a:xfrm>
             <a:off x="756000" y="5078520"/>
-            <a:ext cx="6044400" cy="4807800"/>
+            <a:ext cx="6044040" cy="4807440"/>
           </a:xfrm>
           <a:prstGeom prst="rect">
             <a:avLst/>
@@ -6173,7 +6123,7 @@
         <p:spPr>
           <a:xfrm>
             <a:off x="216360" y="812520"/>
-            <a:ext cx="7123680" cy="4005720"/>
+            <a:ext cx="7123320" cy="4005360"/>
           </a:xfrm>
           <a:prstGeom prst="rect">
             <a:avLst/>
@@ -6196,7 +6146,7 @@
         <p:spPr>
           <a:xfrm>
             <a:off x="756000" y="5078520"/>
-            <a:ext cx="6044400" cy="4807800"/>
+            <a:ext cx="6044040" cy="4807440"/>
           </a:xfrm>
           <a:prstGeom prst="rect">
             <a:avLst/>
@@ -6345,7 +6295,7 @@
         <p:spPr>
           <a:xfrm>
             <a:off x="216360" y="812520"/>
-            <a:ext cx="7123680" cy="4005720"/>
+            <a:ext cx="7123320" cy="4005360"/>
           </a:xfrm>
           <a:prstGeom prst="rect">
             <a:avLst/>
@@ -6368,7 +6318,7 @@
         <p:spPr>
           <a:xfrm>
             <a:off x="756000" y="5078520"/>
-            <a:ext cx="6044400" cy="4807800"/>
+            <a:ext cx="6044040" cy="4807440"/>
           </a:xfrm>
           <a:prstGeom prst="rect">
             <a:avLst/>
@@ -6543,7 +6493,7 @@
         <p:spPr>
           <a:xfrm flipH="1" flipV="1">
             <a:off x="-5760" y="4494240"/>
-            <a:ext cx="10074600" cy="1164600"/>
+            <a:ext cx="10074240" cy="1164240"/>
           </a:xfrm>
           <a:prstGeom prst="flowChartDocument">
             <a:avLst/>
@@ -6935,7 +6885,7 @@
                 <a:srgbClr val="009bdd"/>
               </a:gs>
             </a:gsLst>
-            <a:lin ang="0"/>
+            <a:lin ang="10800000"/>
           </a:gradFill>
           <a:ln w="18000">
             <a:noFill/>
@@ -6987,7 +6937,7 @@
         <p:spPr>
           <a:xfrm>
             <a:off x="0" y="1620000"/>
-            <a:ext cx="8994600" cy="1074600"/>
+            <a:ext cx="8994240" cy="1074240"/>
           </a:xfrm>
           <a:prstGeom prst="rect">
             <a:avLst/>
@@ -7046,7 +6996,7 @@
         <p:spPr>
           <a:xfrm>
             <a:off x="360000" y="2880000"/>
-            <a:ext cx="9354600" cy="1614600"/>
+            <a:ext cx="9354240" cy="1614240"/>
           </a:xfrm>
           <a:prstGeom prst="rect">
             <a:avLst/>
@@ -7320,7 +7270,7 @@
         <p:spPr>
           <a:xfrm>
             <a:off x="360000" y="5220000"/>
-            <a:ext cx="2334600" cy="354600"/>
+            <a:ext cx="2334240" cy="354240"/>
           </a:xfrm>
           <a:prstGeom prst="rect">
             <a:avLst/>
@@ -7398,7 +7348,7 @@
         <p:spPr>
           <a:xfrm>
             <a:off x="3420000" y="5220000"/>
-            <a:ext cx="3234600" cy="354600"/>
+            <a:ext cx="3234240" cy="354240"/>
           </a:xfrm>
           <a:prstGeom prst="rect">
             <a:avLst/>
@@ -7476,7 +7426,7 @@
         <p:spPr>
           <a:xfrm>
             <a:off x="7380000" y="5220000"/>
-            <a:ext cx="2334600" cy="354600"/>
+            <a:ext cx="2334240" cy="354240"/>
           </a:xfrm>
           <a:prstGeom prst="rect">
             <a:avLst/>
@@ -7519,7 +7469,7 @@
                 <a:tab algn="l" pos="0"/>
               </a:tabLst>
             </a:pPr>
-            <a:fld id="{6986B6C9-9FD0-4AA7-BB5D-9FE0973A75F8}" type="slidenum">
+            <a:fld id="{17AE0033-3FD9-4CC4-A458-EEBC0F3A8BCD}" type="slidenum">
               <a:rPr lang="en-AU" sz="1400" b="0" u="none" strike="noStrike">
                 <a:solidFill>
                   <a:srgbClr val="ffffff"/>
@@ -7572,7 +7522,7 @@
         <p:spPr>
           <a:xfrm flipH="1" flipV="1">
             <a:off x="-5760" y="4494240"/>
-            <a:ext cx="10074600" cy="1164600"/>
+            <a:ext cx="10074240" cy="1164240"/>
           </a:xfrm>
           <a:prstGeom prst="flowChartDocument">
             <a:avLst/>
@@ -7964,7 +7914,7 @@
                 <a:srgbClr val="009bdd"/>
               </a:gs>
             </a:gsLst>
-            <a:lin ang="0"/>
+            <a:lin ang="10800000"/>
           </a:gradFill>
           <a:ln w="18000">
             <a:noFill/>
@@ -8016,7 +7966,7 @@
         <p:spPr>
           <a:xfrm>
             <a:off x="0" y="1620000"/>
-            <a:ext cx="8994600" cy="1074600"/>
+            <a:ext cx="8994240" cy="1074240"/>
           </a:xfrm>
           <a:prstGeom prst="rect">
             <a:avLst/>
@@ -8075,7 +8025,7 @@
         <p:spPr>
           <a:xfrm>
             <a:off x="360000" y="2880000"/>
-            <a:ext cx="9354600" cy="1614600"/>
+            <a:ext cx="9354240" cy="1614240"/>
           </a:xfrm>
           <a:prstGeom prst="rect">
             <a:avLst/>
@@ -8349,7 +8299,7 @@
         <p:spPr>
           <a:xfrm>
             <a:off x="360000" y="5220000"/>
-            <a:ext cx="2334600" cy="354600"/>
+            <a:ext cx="2334240" cy="354240"/>
           </a:xfrm>
           <a:prstGeom prst="rect">
             <a:avLst/>
@@ -8427,7 +8377,7 @@
         <p:spPr>
           <a:xfrm>
             <a:off x="3420000" y="5220000"/>
-            <a:ext cx="3234600" cy="354600"/>
+            <a:ext cx="3234240" cy="354240"/>
           </a:xfrm>
           <a:prstGeom prst="rect">
             <a:avLst/>
@@ -8505,7 +8455,7 @@
         <p:spPr>
           <a:xfrm>
             <a:off x="7380000" y="5220000"/>
-            <a:ext cx="2334600" cy="354600"/>
+            <a:ext cx="2334240" cy="354240"/>
           </a:xfrm>
           <a:prstGeom prst="rect">
             <a:avLst/>
@@ -8548,7 +8498,7 @@
                 <a:tab algn="l" pos="0"/>
               </a:tabLst>
             </a:pPr>
-            <a:fld id="{9D24E1D4-CA13-47A9-A480-7523F78576D4}" type="slidenum">
+            <a:fld id="{5AADD3EF-4FDB-4E05-93D5-C219AA6BADD6}" type="slidenum">
               <a:rPr lang="en-AU" sz="1400" b="0" u="none" strike="noStrike">
                 <a:solidFill>
                   <a:srgbClr val="ffffff"/>
@@ -8601,7 +8551,7 @@
         <p:spPr>
           <a:xfrm>
             <a:off x="0" y="0"/>
-            <a:ext cx="10071360" cy="714600"/>
+            <a:ext cx="10071000" cy="714240"/>
           </a:xfrm>
           <a:prstGeom prst="rect">
             <a:avLst/>
@@ -9041,7 +8991,7 @@
         <p:spPr>
           <a:xfrm>
             <a:off x="3240" y="5040000"/>
-            <a:ext cx="10071360" cy="626040"/>
+            <a:ext cx="10071000" cy="625680"/>
           </a:xfrm>
           <a:prstGeom prst="rect">
             <a:avLst/>
@@ -9485,7 +9435,7 @@
         <p:spPr>
           <a:xfrm>
             <a:off x="360000" y="180000"/>
-            <a:ext cx="9354600" cy="472680"/>
+            <a:ext cx="9354240" cy="472320"/>
           </a:xfrm>
           <a:prstGeom prst="rect">
             <a:avLst/>
@@ -9544,7 +9494,7 @@
         <p:spPr>
           <a:xfrm>
             <a:off x="360000" y="1080000"/>
-            <a:ext cx="9354600" cy="3594600"/>
+            <a:ext cx="9354240" cy="3594240"/>
           </a:xfrm>
           <a:prstGeom prst="rect">
             <a:avLst/>
@@ -9818,7 +9768,7 @@
         <p:spPr>
           <a:xfrm>
             <a:off x="360000" y="5220000"/>
-            <a:ext cx="2334600" cy="354600"/>
+            <a:ext cx="2334240" cy="354240"/>
           </a:xfrm>
           <a:prstGeom prst="rect">
             <a:avLst/>
@@ -9896,7 +9846,7 @@
         <p:spPr>
           <a:xfrm>
             <a:off x="3420000" y="5220000"/>
-            <a:ext cx="3234600" cy="354600"/>
+            <a:ext cx="3234240" cy="354240"/>
           </a:xfrm>
           <a:prstGeom prst="rect">
             <a:avLst/>
@@ -9974,7 +9924,7 @@
         <p:spPr>
           <a:xfrm>
             <a:off x="7380000" y="5220000"/>
-            <a:ext cx="2334600" cy="354600"/>
+            <a:ext cx="2334240" cy="354240"/>
           </a:xfrm>
           <a:prstGeom prst="rect">
             <a:avLst/>
@@ -10017,7 +9967,7 @@
                 <a:tab algn="l" pos="0"/>
               </a:tabLst>
             </a:pPr>
-            <a:fld id="{FFB159AE-5A59-4FE9-AFA5-B7E997EBCDA2}" type="slidenum">
+            <a:fld id="{D7B69EAD-4D02-4CF2-9606-DAA9F2DCBA33}" type="slidenum">
               <a:rPr lang="en-AU" sz="1400" b="0" u="none" strike="noStrike">
                 <a:solidFill>
                   <a:srgbClr val="ffffff"/>
@@ -10070,7 +10020,7 @@
         <p:spPr>
           <a:xfrm flipH="1" flipV="1">
             <a:off x="-5040" y="4494960"/>
-            <a:ext cx="10075320" cy="1165320"/>
+            <a:ext cx="10074960" cy="1164960"/>
           </a:xfrm>
           <a:prstGeom prst="flowChartDocument">
             <a:avLst/>
@@ -10462,7 +10412,7 @@
                 <a:srgbClr val="009bdd"/>
               </a:gs>
             </a:gsLst>
-            <a:lin ang="0"/>
+            <a:lin ang="10800000"/>
           </a:gradFill>
           <a:ln w="18000">
             <a:noFill/>
@@ -10514,7 +10464,7 @@
         <p:spPr>
           <a:xfrm>
             <a:off x="0" y="1620000"/>
-            <a:ext cx="8995320" cy="1075320"/>
+            <a:ext cx="8994960" cy="1074960"/>
           </a:xfrm>
           <a:prstGeom prst="rect">
             <a:avLst/>
@@ -10573,7 +10523,7 @@
         <p:spPr>
           <a:xfrm>
             <a:off x="360000" y="2880000"/>
-            <a:ext cx="9355320" cy="1615320"/>
+            <a:ext cx="9354960" cy="1614960"/>
           </a:xfrm>
           <a:prstGeom prst="rect">
             <a:avLst/>
@@ -10847,7 +10797,7 @@
         <p:spPr>
           <a:xfrm>
             <a:off x="360000" y="5220000"/>
-            <a:ext cx="2335320" cy="355320"/>
+            <a:ext cx="2334960" cy="354960"/>
           </a:xfrm>
           <a:prstGeom prst="rect">
             <a:avLst/>
@@ -10925,7 +10875,7 @@
         <p:spPr>
           <a:xfrm>
             <a:off x="3420000" y="5220000"/>
-            <a:ext cx="3235320" cy="355320"/>
+            <a:ext cx="3234960" cy="354960"/>
           </a:xfrm>
           <a:prstGeom prst="rect">
             <a:avLst/>
@@ -11003,7 +10953,7 @@
         <p:spPr>
           <a:xfrm>
             <a:off x="7380000" y="5220000"/>
-            <a:ext cx="2335320" cy="355320"/>
+            <a:ext cx="2334960" cy="354960"/>
           </a:xfrm>
           <a:prstGeom prst="rect">
             <a:avLst/>
@@ -11046,7 +10996,7 @@
                 <a:tab algn="l" pos="0"/>
               </a:tabLst>
             </a:pPr>
-            <a:fld id="{B38132CD-729D-4782-AB3C-9E7AD9ADFD07}" type="slidenum">
+            <a:fld id="{AD47B656-73E5-4768-8D7B-702B0E4FD726}" type="slidenum">
               <a:rPr lang="en-AU" sz="1400" b="0" u="none" strike="noStrike">
                 <a:solidFill>
                   <a:srgbClr val="ffffff"/>
@@ -11099,7 +11049,7 @@
         <p:spPr>
           <a:xfrm>
             <a:off x="0" y="0"/>
-            <a:ext cx="10072080" cy="715320"/>
+            <a:ext cx="10071720" cy="714960"/>
           </a:xfrm>
           <a:prstGeom prst="rect">
             <a:avLst/>
@@ -11539,7 +11489,7 @@
         <p:spPr>
           <a:xfrm>
             <a:off x="3240" y="5040000"/>
-            <a:ext cx="10072080" cy="626760"/>
+            <a:ext cx="10071720" cy="626400"/>
           </a:xfrm>
           <a:prstGeom prst="rect">
             <a:avLst/>
@@ -11983,7 +11933,7 @@
         <p:spPr>
           <a:xfrm>
             <a:off x="360000" y="180000"/>
-            <a:ext cx="9355320" cy="473400"/>
+            <a:ext cx="9354960" cy="473040"/>
           </a:xfrm>
           <a:prstGeom prst="rect">
             <a:avLst/>
@@ -12042,7 +11992,7 @@
         <p:spPr>
           <a:xfrm>
             <a:off x="360000" y="1080000"/>
-            <a:ext cx="9355320" cy="3595320"/>
+            <a:ext cx="9354960" cy="3594960"/>
           </a:xfrm>
           <a:prstGeom prst="rect">
             <a:avLst/>
@@ -12316,7 +12266,7 @@
         <p:spPr>
           <a:xfrm>
             <a:off x="360000" y="5220000"/>
-            <a:ext cx="2335320" cy="355320"/>
+            <a:ext cx="2334960" cy="354960"/>
           </a:xfrm>
           <a:prstGeom prst="rect">
             <a:avLst/>
@@ -12394,7 +12344,7 @@
         <p:spPr>
           <a:xfrm>
             <a:off x="3420000" y="5220000"/>
-            <a:ext cx="3235320" cy="355320"/>
+            <a:ext cx="3234960" cy="354960"/>
           </a:xfrm>
           <a:prstGeom prst="rect">
             <a:avLst/>
@@ -12472,7 +12422,7 @@
         <p:spPr>
           <a:xfrm>
             <a:off x="7380000" y="5220000"/>
-            <a:ext cx="2335320" cy="355320"/>
+            <a:ext cx="2334960" cy="354960"/>
           </a:xfrm>
           <a:prstGeom prst="rect">
             <a:avLst/>
@@ -12515,7 +12465,7 @@
                 <a:tab algn="l" pos="0"/>
               </a:tabLst>
             </a:pPr>
-            <a:fld id="{1F0F2E02-4A4B-4D1A-91A5-3FD8FBBEBFF0}" type="slidenum">
+            <a:fld id="{68433789-1C67-4253-9F97-4C4459794F16}" type="slidenum">
               <a:rPr lang="en-AU" sz="1400" b="0" u="none" strike="noStrike">
                 <a:solidFill>
                   <a:srgbClr val="ffffff"/>
@@ -12626,8 +12576,8 @@
         </p:nvSpPr>
         <p:spPr>
           <a:xfrm>
-            <a:off x="0" y="1614600"/>
-            <a:ext cx="8994600" cy="1085400"/>
+            <a:off x="0" y="1614240"/>
+            <a:ext cx="8994240" cy="1085760"/>
           </a:xfrm>
           <a:prstGeom prst="rect">
             <a:avLst/>
@@ -12715,8 +12665,8 @@
         </p:nvSpPr>
         <p:spPr>
           <a:xfrm>
-            <a:off x="360000" y="162720"/>
-            <a:ext cx="9354600" cy="507240"/>
+            <a:off x="360000" y="162360"/>
+            <a:ext cx="9354240" cy="507600"/>
           </a:xfrm>
           <a:prstGeom prst="rect">
             <a:avLst/>
@@ -12775,7 +12725,7 @@
         <p:spPr>
           <a:xfrm>
             <a:off x="360000" y="1080000"/>
-            <a:ext cx="9354600" cy="3594600"/>
+            <a:ext cx="9354240" cy="3594240"/>
           </a:xfrm>
           <a:prstGeom prst="rect">
             <a:avLst/>
@@ -12967,7 +12917,7 @@
         <p:txBody>
           <a:bodyPr/>
           <a:p>
-            <a:fld id="{55A3C5ED-A489-4816-891A-A832AAAA5022}" type="slidenum">
+            <a:fld id="{80F20A9B-1DFC-411A-B39D-D7F44283CAE4}" type="slidenum">
               <a:t>10</a:t>
             </a:fld>
           </a:p>
@@ -13015,8 +12965,8 @@
         </p:nvSpPr>
         <p:spPr>
           <a:xfrm>
-            <a:off x="360000" y="162720"/>
-            <a:ext cx="9354600" cy="507240"/>
+            <a:off x="360000" y="162360"/>
+            <a:ext cx="9354240" cy="507600"/>
           </a:xfrm>
           <a:prstGeom prst="rect">
             <a:avLst/>
@@ -13075,7 +13025,7 @@
         <p:spPr>
           <a:xfrm>
             <a:off x="360000" y="1080000"/>
-            <a:ext cx="9354600" cy="3594600"/>
+            <a:ext cx="9354240" cy="3594240"/>
           </a:xfrm>
           <a:prstGeom prst="rect">
             <a:avLst/>
@@ -13277,7 +13227,7 @@
         <p:txBody>
           <a:bodyPr/>
           <a:p>
-            <a:fld id="{529C4831-17FA-4BB6-AC21-28476312DA88}" type="slidenum">
+            <a:fld id="{4B232C90-DA55-4A27-A38C-E5CC042A93DF}" type="slidenum">
               <a:t>11</a:t>
             </a:fld>
           </a:p>
@@ -13325,8 +13275,8 @@
         </p:nvSpPr>
         <p:spPr>
           <a:xfrm>
-            <a:off x="0" y="1615320"/>
-            <a:ext cx="8995320" cy="1084680"/>
+            <a:off x="0" y="1614960"/>
+            <a:ext cx="8994960" cy="1085040"/>
           </a:xfrm>
           <a:prstGeom prst="rect">
             <a:avLst/>
@@ -13414,8 +13364,8 @@
         </p:nvSpPr>
         <p:spPr>
           <a:xfrm>
-            <a:off x="360000" y="162720"/>
-            <a:ext cx="9354600" cy="507240"/>
+            <a:off x="360000" y="162360"/>
+            <a:ext cx="9354240" cy="507600"/>
           </a:xfrm>
           <a:prstGeom prst="rect">
             <a:avLst/>
@@ -13480,7 +13430,7 @@
         <p:spPr>
           <a:xfrm>
             <a:off x="360000" y="1080000"/>
-            <a:ext cx="9354600" cy="3594600"/>
+            <a:ext cx="9354240" cy="3594240"/>
           </a:xfrm>
           <a:prstGeom prst="rect">
             <a:avLst/>
@@ -13700,7 +13650,7 @@
         <p:txBody>
           <a:bodyPr/>
           <a:p>
-            <a:fld id="{59851FB4-641D-450F-922F-45FF9FD6EF7A}" type="slidenum">
+            <a:fld id="{BBD6E0F9-2131-448C-98A8-F232618F616A}" type="slidenum">
               <a:t>13</a:t>
             </a:fld>
           </a:p>
@@ -13748,8 +13698,8 @@
         </p:nvSpPr>
         <p:spPr>
           <a:xfrm>
-            <a:off x="360000" y="162720"/>
-            <a:ext cx="9354600" cy="507240"/>
+            <a:off x="360000" y="162360"/>
+            <a:ext cx="9354240" cy="507600"/>
           </a:xfrm>
           <a:prstGeom prst="rect">
             <a:avLst/>
@@ -13814,7 +13764,7 @@
         <p:spPr>
           <a:xfrm>
             <a:off x="360000" y="1080000"/>
-            <a:ext cx="9354600" cy="3594600"/>
+            <a:ext cx="9354240" cy="3594240"/>
           </a:xfrm>
           <a:prstGeom prst="rect">
             <a:avLst/>
@@ -14034,7 +13984,7 @@
         <p:txBody>
           <a:bodyPr/>
           <a:p>
-            <a:fld id="{AA2CA5A1-B1CE-4911-A91D-4A17023E8E01}" type="slidenum">
+            <a:fld id="{8DDFB701-0D07-4BD2-A76F-E3870BD3A336}" type="slidenum">
               <a:t>14</a:t>
             </a:fld>
           </a:p>
@@ -14082,8 +14032,8 @@
         </p:nvSpPr>
         <p:spPr>
           <a:xfrm>
-            <a:off x="360000" y="162720"/>
-            <a:ext cx="9354600" cy="507240"/>
+            <a:off x="360000" y="162360"/>
+            <a:ext cx="9354240" cy="507600"/>
           </a:xfrm>
           <a:prstGeom prst="rect">
             <a:avLst/>
@@ -14148,7 +14098,7 @@
         <p:spPr>
           <a:xfrm>
             <a:off x="360000" y="1080000"/>
-            <a:ext cx="9354600" cy="3594600"/>
+            <a:ext cx="9354240" cy="3594240"/>
           </a:xfrm>
           <a:prstGeom prst="rect">
             <a:avLst/>
@@ -14286,7 +14236,7 @@
         <p:txBody>
           <a:bodyPr/>
           <a:p>
-            <a:fld id="{64B7BCDA-F555-49ED-A0E9-45DEE206486B}" type="slidenum">
+            <a:fld id="{E878B37C-8C20-41C5-8AC1-EC5D6A760BA3}" type="slidenum">
               <a:t>15</a:t>
             </a:fld>
           </a:p>
@@ -14334,8 +14284,8 @@
         </p:nvSpPr>
         <p:spPr>
           <a:xfrm>
-            <a:off x="360000" y="162720"/>
-            <a:ext cx="9354600" cy="507240"/>
+            <a:off x="360000" y="162360"/>
+            <a:ext cx="9354240" cy="507600"/>
           </a:xfrm>
           <a:prstGeom prst="rect">
             <a:avLst/>
@@ -15654,7 +15604,7 @@
         <p:txBody>
           <a:bodyPr/>
           <a:p>
-            <a:fld id="{4602A5D7-B0FD-4CC6-A2F3-8968049111B0}" type="slidenum">
+            <a:fld id="{69365695-044A-49F2-988A-2C1E02648FC5}" type="slidenum">
               <a:t>16</a:t>
             </a:fld>
           </a:p>
@@ -15702,8 +15652,8 @@
         </p:nvSpPr>
         <p:spPr>
           <a:xfrm>
-            <a:off x="0" y="1615320"/>
-            <a:ext cx="8995320" cy="1084680"/>
+            <a:off x="0" y="1614960"/>
+            <a:ext cx="8994960" cy="1085040"/>
           </a:xfrm>
           <a:prstGeom prst="rect">
             <a:avLst/>
@@ -15791,8 +15741,8 @@
         </p:nvSpPr>
         <p:spPr>
           <a:xfrm>
-            <a:off x="360000" y="162720"/>
-            <a:ext cx="9354600" cy="507240"/>
+            <a:off x="360000" y="162360"/>
+            <a:ext cx="9354240" cy="507600"/>
           </a:xfrm>
           <a:prstGeom prst="rect">
             <a:avLst/>
@@ -17333,7 +17283,7 @@
         <p:txBody>
           <a:bodyPr/>
           <a:p>
-            <a:fld id="{AE4FD9B3-00FE-4DF5-ADA6-AB21658FBCD1}" type="slidenum">
+            <a:fld id="{A98EF663-2BD1-4FF6-BB8D-6F8D2DAC5D9B}" type="slidenum">
               <a:t>18</a:t>
             </a:fld>
           </a:p>
@@ -17381,8 +17331,8 @@
         </p:nvSpPr>
         <p:spPr>
           <a:xfrm>
-            <a:off x="0" y="1615320"/>
-            <a:ext cx="8995320" cy="1084680"/>
+            <a:off x="0" y="1614960"/>
+            <a:ext cx="8994960" cy="1085040"/>
           </a:xfrm>
           <a:prstGeom prst="rect">
             <a:avLst/>
@@ -17470,8 +17420,8 @@
         </p:nvSpPr>
         <p:spPr>
           <a:xfrm>
-            <a:off x="360000" y="162720"/>
-            <a:ext cx="9354600" cy="507240"/>
+            <a:off x="360000" y="162360"/>
+            <a:ext cx="9354240" cy="507600"/>
           </a:xfrm>
           <a:prstGeom prst="rect">
             <a:avLst/>
@@ -17530,7 +17480,7 @@
         <p:spPr>
           <a:xfrm>
             <a:off x="360000" y="1080000"/>
-            <a:ext cx="9354600" cy="3594600"/>
+            <a:ext cx="9354240" cy="3594240"/>
           </a:xfrm>
           <a:prstGeom prst="rect">
             <a:avLst/>
@@ -17701,7 +17651,7 @@
         <p:txBody>
           <a:bodyPr/>
           <a:p>
-            <a:fld id="{B968249C-A995-4FC7-80AE-B876843687D6}" type="slidenum">
+            <a:fld id="{409BBDF7-846D-481C-A03D-FCEF726163C1}" type="slidenum">
               <a:t>2</a:t>
             </a:fld>
           </a:p>
@@ -17749,8 +17699,8 @@
         </p:nvSpPr>
         <p:spPr>
           <a:xfrm>
-            <a:off x="360000" y="162720"/>
-            <a:ext cx="9354600" cy="507240"/>
+            <a:off x="360000" y="162360"/>
+            <a:ext cx="9354240" cy="507600"/>
           </a:xfrm>
           <a:prstGeom prst="rect">
             <a:avLst/>
@@ -17810,7 +17760,7 @@
         </p:nvGraphicFramePr>
         <p:xfrm>
           <a:off x="1241280" y="948600"/>
-          <a:ext cx="7558200" cy="3963600"/>
+          <a:ext cx="7558200" cy="4755600"/>
         </p:xfrm>
         <a:graphic>
           <a:graphicData uri="http://schemas.openxmlformats.org/drawingml/2006/table">
@@ -17822,7 +17772,249 @@
                 <a:gridCol w="1889640"/>
                 <a:gridCol w="1889640"/>
               </a:tblGrid>
-              <a:tr h="792360">
+              <a:tr h="374040">
+                <a:tc>
+                  <a:txBody>
+                    <a:bodyPr lIns="36000" rIns="36000" anchor="t">
+                      <a:noAutofit/>
+                    </a:bodyPr>
+                    <a:p>
+                      <a:pPr>
+                        <a:lnSpc>
+                          <a:spcPct val="100000"/>
+                        </a:lnSpc>
+                      </a:pPr>
+                      <a:r>
+                        <a:rPr lang="en-AU" sz="1200" b="0" u="none" strike="noStrike">
+                          <a:solidFill>
+                            <a:srgbClr val="000000"/>
+                          </a:solidFill>
+                          <a:effectLst/>
+                          <a:uFillTx/>
+                          <a:latin typeface="Arial"/>
+                        </a:rPr>
+                        <a:t>Host</a:t>
+                      </a:r>
+                      <a:endParaRPr lang="en-AU" sz="1200" b="0" u="none" strike="noStrike">
+                        <a:solidFill>
+                          <a:srgbClr val="000000"/>
+                        </a:solidFill>
+                        <a:effectLst/>
+                        <a:uFillTx/>
+                        <a:latin typeface="Arial"/>
+                      </a:endParaRPr>
+                    </a:p>
+                  </a:txBody>
+                  <a:tcPr anchor="t" marL="36000" marR="36000" marT="45720" marB="45720">
+                    <a:lnL w="7200">
+                      <a:solidFill>
+                        <a:srgbClr val="000000"/>
+                      </a:solidFill>
+                      <a:prstDash val="solid"/>
+                    </a:lnL>
+                    <a:lnR w="7200">
+                      <a:solidFill>
+                        <a:srgbClr val="000000"/>
+                      </a:solidFill>
+                      <a:prstDash val="solid"/>
+                    </a:lnR>
+                    <a:lnT w="7200">
+                      <a:solidFill>
+                        <a:srgbClr val="000000"/>
+                      </a:solidFill>
+                      <a:prstDash val="solid"/>
+                    </a:lnT>
+                    <a:lnB w="7200">
+                      <a:solidFill>
+                        <a:srgbClr val="000000"/>
+                      </a:solidFill>
+                      <a:prstDash val="solid"/>
+                    </a:lnB>
+                    <a:noFill/>
+                  </a:tcPr>
+                </a:tc>
+                <a:tc>
+                  <a:txBody>
+                    <a:bodyPr lIns="36000" rIns="36000" anchor="t">
+                      <a:noAutofit/>
+                    </a:bodyPr>
+                    <a:p>
+                      <a:pPr>
+                        <a:lnSpc>
+                          <a:spcPct val="100000"/>
+                        </a:lnSpc>
+                      </a:pPr>
+                      <a:r>
+                        <a:rPr lang="en-AU" sz="1200" b="0" u="none" strike="noStrike">
+                          <a:solidFill>
+                            <a:srgbClr val="000000"/>
+                          </a:solidFill>
+                          <a:effectLst/>
+                          <a:uFillTx/>
+                          <a:latin typeface="Arial"/>
+                        </a:rPr>
+                        <a:t>Provider</a:t>
+                      </a:r>
+                      <a:endParaRPr lang="en-AU" sz="1200" b="0" u="none" strike="noStrike">
+                        <a:solidFill>
+                          <a:srgbClr val="000000"/>
+                        </a:solidFill>
+                        <a:effectLst/>
+                        <a:uFillTx/>
+                        <a:latin typeface="Arial"/>
+                      </a:endParaRPr>
+                    </a:p>
+                  </a:txBody>
+                  <a:tcPr anchor="t" marL="36000" marR="36000" marT="45720" marB="45720">
+                    <a:lnL w="7200">
+                      <a:solidFill>
+                        <a:srgbClr val="000000"/>
+                      </a:solidFill>
+                      <a:prstDash val="solid"/>
+                    </a:lnL>
+                    <a:lnR w="7200">
+                      <a:solidFill>
+                        <a:srgbClr val="000000"/>
+                      </a:solidFill>
+                      <a:prstDash val="solid"/>
+                    </a:lnR>
+                    <a:lnT w="7200">
+                      <a:solidFill>
+                        <a:srgbClr val="000000"/>
+                      </a:solidFill>
+                      <a:prstDash val="solid"/>
+                    </a:lnT>
+                    <a:lnB w="7200">
+                      <a:solidFill>
+                        <a:srgbClr val="000000"/>
+                      </a:solidFill>
+                      <a:prstDash val="solid"/>
+                    </a:lnB>
+                    <a:noFill/>
+                  </a:tcPr>
+                </a:tc>
+                <a:tc>
+                  <a:txBody>
+                    <a:bodyPr lIns="36000" rIns="36000" anchor="t">
+                      <a:noAutofit/>
+                    </a:bodyPr>
+                    <a:p>
+                      <a:pPr>
+                        <a:lnSpc>
+                          <a:spcPct val="100000"/>
+                        </a:lnSpc>
+                      </a:pPr>
+                      <a:r>
+                        <a:rPr lang="en-AU" sz="1200" b="0" u="none" strike="noStrike">
+                          <a:solidFill>
+                            <a:srgbClr val="000000"/>
+                          </a:solidFill>
+                          <a:effectLst/>
+                          <a:uFillTx/>
+                          <a:latin typeface="Arial"/>
+                        </a:rPr>
+                        <a:t>Name</a:t>
+                      </a:r>
+                      <a:endParaRPr lang="en-AU" sz="1200" b="0" u="none" strike="noStrike">
+                        <a:solidFill>
+                          <a:srgbClr val="000000"/>
+                        </a:solidFill>
+                        <a:effectLst/>
+                        <a:uFillTx/>
+                        <a:latin typeface="Arial"/>
+                      </a:endParaRPr>
+                    </a:p>
+                  </a:txBody>
+                  <a:tcPr anchor="t" marL="36000" marR="36000" marT="45720" marB="45720">
+                    <a:lnL w="7200">
+                      <a:solidFill>
+                        <a:srgbClr val="000000"/>
+                      </a:solidFill>
+                      <a:prstDash val="solid"/>
+                    </a:lnL>
+                    <a:lnR w="7200">
+                      <a:solidFill>
+                        <a:srgbClr val="000000"/>
+                      </a:solidFill>
+                      <a:prstDash val="solid"/>
+                    </a:lnR>
+                    <a:lnT w="7200">
+                      <a:solidFill>
+                        <a:srgbClr val="000000"/>
+                      </a:solidFill>
+                      <a:prstDash val="solid"/>
+                    </a:lnT>
+                    <a:lnB w="7200">
+                      <a:solidFill>
+                        <a:srgbClr val="000000"/>
+                      </a:solidFill>
+                      <a:prstDash val="solid"/>
+                    </a:lnB>
+                    <a:noFill/>
+                  </a:tcPr>
+                </a:tc>
+                <a:tc>
+                  <a:txBody>
+                    <a:bodyPr lIns="36000" rIns="36000" anchor="t">
+                      <a:noAutofit/>
+                    </a:bodyPr>
+                    <a:p>
+                      <a:pPr>
+                        <a:lnSpc>
+                          <a:spcPct val="100000"/>
+                        </a:lnSpc>
+                      </a:pPr>
+                      <a:r>
+                        <a:rPr lang="en-AU" sz="1200" b="0" u="none" strike="noStrike">
+                          <a:solidFill>
+                            <a:srgbClr val="000000"/>
+                          </a:solidFill>
+                          <a:effectLst/>
+                          <a:uFillTx/>
+                          <a:latin typeface="Arial"/>
+                        </a:rPr>
+                        <a:t>Performance on test data</a:t>
+                      </a:r>
+                      <a:endParaRPr lang="en-AU" sz="1200" b="0" u="none" strike="noStrike">
+                        <a:solidFill>
+                          <a:srgbClr val="000000"/>
+                        </a:solidFill>
+                        <a:effectLst/>
+                        <a:uFillTx/>
+                        <a:latin typeface="Arial"/>
+                      </a:endParaRPr>
+                    </a:p>
+                  </a:txBody>
+                  <a:tcPr anchor="t" marL="36000" marR="36000" marT="45720" marB="45720">
+                    <a:lnL w="7200">
+                      <a:solidFill>
+                        <a:srgbClr val="000000"/>
+                      </a:solidFill>
+                      <a:prstDash val="solid"/>
+                    </a:lnL>
+                    <a:lnR w="7200">
+                      <a:solidFill>
+                        <a:srgbClr val="000000"/>
+                      </a:solidFill>
+                      <a:prstDash val="solid"/>
+                    </a:lnR>
+                    <a:lnT w="7200">
+                      <a:solidFill>
+                        <a:srgbClr val="000000"/>
+                      </a:solidFill>
+                      <a:prstDash val="solid"/>
+                    </a:lnT>
+                    <a:lnB w="7200">
+                      <a:solidFill>
+                        <a:srgbClr val="000000"/>
+                      </a:solidFill>
+                      <a:prstDash val="solid"/>
+                    </a:lnB>
+                    <a:noFill/>
+                  </a:tcPr>
+                </a:tc>
+              </a:tr>
+              <a:tr h="491040">
                 <a:tc>
                   <a:txBody>
                     <a:bodyPr lIns="36000" rIns="36000" anchor="t">
@@ -17842,58 +18034,10 @@
                           <a:effectLst/>
                           <a:uFillTx/>
                           <a:latin typeface="Arial"/>
+                          <a:ea typeface="Microsoft YaHei"/>
                         </a:rPr>
-                        <a:t>Host</a:t>
+                        <a:t>LM Studio l</a:t>
                       </a:r>
-                      <a:endParaRPr lang="en-AU" sz="1800" b="0" u="none" strike="noStrike">
-                        <a:solidFill>
-                          <a:srgbClr val="000000"/>
-                        </a:solidFill>
-                        <a:effectLst/>
-                        <a:uFillTx/>
-                        <a:latin typeface="Arial"/>
-                      </a:endParaRPr>
-                    </a:p>
-                  </a:txBody>
-                  <a:tcPr anchor="t" marL="36000" marR="36000" marT="45720" marB="45720">
-                    <a:lnL w="7200">
-                      <a:solidFill>
-                        <a:srgbClr val="000000"/>
-                      </a:solidFill>
-                      <a:prstDash val="solid"/>
-                    </a:lnL>
-                    <a:lnR w="7200">
-                      <a:solidFill>
-                        <a:srgbClr val="000000"/>
-                      </a:solidFill>
-                      <a:prstDash val="solid"/>
-                    </a:lnR>
-                    <a:lnT w="7200">
-                      <a:solidFill>
-                        <a:srgbClr val="000000"/>
-                      </a:solidFill>
-                      <a:prstDash val="solid"/>
-                    </a:lnT>
-                    <a:lnB w="7200">
-                      <a:solidFill>
-                        <a:srgbClr val="000000"/>
-                      </a:solidFill>
-                      <a:prstDash val="solid"/>
-                    </a:lnB>
-                    <a:noFill/>
-                  </a:tcPr>
-                </a:tc>
-                <a:tc>
-                  <a:txBody>
-                    <a:bodyPr lIns="36000" rIns="36000" anchor="t">
-                      <a:noAutofit/>
-                    </a:bodyPr>
-                    <a:p>
-                      <a:pPr>
-                        <a:lnSpc>
-                          <a:spcPct val="100000"/>
-                        </a:lnSpc>
-                      </a:pPr>
                       <a:r>
                         <a:rPr lang="en-AU" sz="1800" b="0" u="none" strike="noStrike">
                           <a:solidFill>
@@ -17903,189 +18047,7 @@
                           <a:uFillTx/>
                           <a:latin typeface="Arial"/>
                         </a:rPr>
-                        <a:t>Provider</a:t>
-                      </a:r>
-                      <a:endParaRPr lang="en-AU" sz="1800" b="0" u="none" strike="noStrike">
-                        <a:solidFill>
-                          <a:srgbClr val="000000"/>
-                        </a:solidFill>
-                        <a:effectLst/>
-                        <a:uFillTx/>
-                        <a:latin typeface="Arial"/>
-                      </a:endParaRPr>
-                    </a:p>
-                  </a:txBody>
-                  <a:tcPr anchor="t" marL="36000" marR="36000" marT="45720" marB="45720">
-                    <a:lnL w="7200">
-                      <a:solidFill>
-                        <a:srgbClr val="000000"/>
-                      </a:solidFill>
-                      <a:prstDash val="solid"/>
-                    </a:lnL>
-                    <a:lnR w="7200">
-                      <a:solidFill>
-                        <a:srgbClr val="000000"/>
-                      </a:solidFill>
-                      <a:prstDash val="solid"/>
-                    </a:lnR>
-                    <a:lnT w="7200">
-                      <a:solidFill>
-                        <a:srgbClr val="000000"/>
-                      </a:solidFill>
-                      <a:prstDash val="solid"/>
-                    </a:lnT>
-                    <a:lnB w="7200">
-                      <a:solidFill>
-                        <a:srgbClr val="000000"/>
-                      </a:solidFill>
-                      <a:prstDash val="solid"/>
-                    </a:lnB>
-                    <a:noFill/>
-                  </a:tcPr>
-                </a:tc>
-                <a:tc>
-                  <a:txBody>
-                    <a:bodyPr lIns="36000" rIns="36000" anchor="t">
-                      <a:noAutofit/>
-                    </a:bodyPr>
-                    <a:p>
-                      <a:pPr>
-                        <a:lnSpc>
-                          <a:spcPct val="100000"/>
-                        </a:lnSpc>
-                      </a:pPr>
-                      <a:r>
-                        <a:rPr lang="en-AU" sz="1800" b="0" u="none" strike="noStrike">
-                          <a:solidFill>
-                            <a:srgbClr val="000000"/>
-                          </a:solidFill>
-                          <a:effectLst/>
-                          <a:uFillTx/>
-                          <a:latin typeface="Arial"/>
-                        </a:rPr>
-                        <a:t>Name</a:t>
-                      </a:r>
-                      <a:endParaRPr lang="en-AU" sz="1800" b="0" u="none" strike="noStrike">
-                        <a:solidFill>
-                          <a:srgbClr val="000000"/>
-                        </a:solidFill>
-                        <a:effectLst/>
-                        <a:uFillTx/>
-                        <a:latin typeface="Arial"/>
-                      </a:endParaRPr>
-                    </a:p>
-                  </a:txBody>
-                  <a:tcPr anchor="t" marL="36000" marR="36000" marT="45720" marB="45720">
-                    <a:lnL w="7200">
-                      <a:solidFill>
-                        <a:srgbClr val="000000"/>
-                      </a:solidFill>
-                      <a:prstDash val="solid"/>
-                    </a:lnL>
-                    <a:lnR w="7200">
-                      <a:solidFill>
-                        <a:srgbClr val="000000"/>
-                      </a:solidFill>
-                      <a:prstDash val="solid"/>
-                    </a:lnR>
-                    <a:lnT w="7200">
-                      <a:solidFill>
-                        <a:srgbClr val="000000"/>
-                      </a:solidFill>
-                      <a:prstDash val="solid"/>
-                    </a:lnT>
-                    <a:lnB w="7200">
-                      <a:solidFill>
-                        <a:srgbClr val="000000"/>
-                      </a:solidFill>
-                      <a:prstDash val="solid"/>
-                    </a:lnB>
-                    <a:noFill/>
-                  </a:tcPr>
-                </a:tc>
-                <a:tc>
-                  <a:txBody>
-                    <a:bodyPr lIns="36000" rIns="36000" anchor="t">
-                      <a:noAutofit/>
-                    </a:bodyPr>
-                    <a:p>
-                      <a:pPr>
-                        <a:lnSpc>
-                          <a:spcPct val="100000"/>
-                        </a:lnSpc>
-                      </a:pPr>
-                      <a:r>
-                        <a:rPr lang="en-AU" sz="1800" b="0" u="none" strike="noStrike">
-                          <a:solidFill>
-                            <a:srgbClr val="000000"/>
-                          </a:solidFill>
-                          <a:effectLst/>
-                          <a:uFillTx/>
-                          <a:latin typeface="Arial"/>
-                        </a:rPr>
-                        <a:t>Performance on test data</a:t>
-                      </a:r>
-                      <a:endParaRPr lang="en-AU" sz="1800" b="0" u="none" strike="noStrike">
-                        <a:solidFill>
-                          <a:srgbClr val="000000"/>
-                        </a:solidFill>
-                        <a:effectLst/>
-                        <a:uFillTx/>
-                        <a:latin typeface="Arial"/>
-                      </a:endParaRPr>
-                    </a:p>
-                  </a:txBody>
-                  <a:tcPr anchor="t" marL="36000" marR="36000" marT="45720" marB="45720">
-                    <a:lnL w="7200">
-                      <a:solidFill>
-                        <a:srgbClr val="000000"/>
-                      </a:solidFill>
-                      <a:prstDash val="solid"/>
-                    </a:lnL>
-                    <a:lnR w="7200">
-                      <a:solidFill>
-                        <a:srgbClr val="000000"/>
-                      </a:solidFill>
-                      <a:prstDash val="solid"/>
-                    </a:lnR>
-                    <a:lnT w="7200">
-                      <a:solidFill>
-                        <a:srgbClr val="000000"/>
-                      </a:solidFill>
-                      <a:prstDash val="solid"/>
-                    </a:lnT>
-                    <a:lnB w="7200">
-                      <a:solidFill>
-                        <a:srgbClr val="000000"/>
-                      </a:solidFill>
-                      <a:prstDash val="solid"/>
-                    </a:lnB>
-                    <a:noFill/>
-                  </a:tcPr>
-                </a:tc>
-              </a:tr>
-              <a:tr h="792360">
-                <a:tc>
-                  <a:txBody>
-                    <a:bodyPr lIns="36000" rIns="36000" anchor="t">
-                      <a:noAutofit/>
-                    </a:bodyPr>
-                    <a:p>
-                      <a:pPr>
-                        <a:lnSpc>
-                          <a:spcPct val="100000"/>
-                        </a:lnSpc>
-                      </a:pPr>
-                      <a:r>
-                        <a:rPr lang="en-AU" sz="1800" b="0" u="none" strike="noStrike">
-                          <a:solidFill>
-                            <a:srgbClr val="000000"/>
-                          </a:solidFill>
-                          <a:effectLst/>
-                          <a:uFillTx/>
-                          <a:latin typeface="Arial"/>
-                        </a:rPr>
-                        <a:t>Local</a:t>
+                        <a:t>ocal </a:t>
                       </a:r>
                       <a:endParaRPr lang="en-AU" sz="1800" b="0" u="none" strike="noStrike">
                         <a:solidFill>
@@ -18306,7 +18268,7 @@
                   </a:tcPr>
                 </a:tc>
               </a:tr>
-              <a:tr h="792360">
+              <a:tr h="484920">
                 <a:tc>
                   <a:txBody>
                     <a:bodyPr lIns="36000" rIns="36000" anchor="t">
@@ -18326,8 +18288,20 @@
                           <a:effectLst/>
                           <a:uFillTx/>
                           <a:latin typeface="Arial"/>
+                          <a:ea typeface="Microsoft YaHei"/>
                         </a:rPr>
-                        <a:t>Local</a:t>
+                        <a:t>LM Studio l</a:t>
+                      </a:r>
+                      <a:r>
+                        <a:rPr lang="en-AU" sz="1800" b="0" u="none" strike="noStrike">
+                          <a:solidFill>
+                            <a:srgbClr val="000000"/>
+                          </a:solidFill>
+                          <a:effectLst/>
+                          <a:uFillTx/>
+                          <a:latin typeface="Arial"/>
+                        </a:rPr>
+                        <a:t>ocal </a:t>
                       </a:r>
                       <a:endParaRPr lang="en-AU" sz="1800" b="0" u="none" strike="noStrike">
                         <a:solidFill>
@@ -18548,7 +18522,7 @@
                   </a:tcPr>
                 </a:tc>
               </a:tr>
-              <a:tr h="792360">
+              <a:tr h="478440">
                 <a:tc>
                   <a:txBody>
                     <a:bodyPr lIns="36000" rIns="36000" anchor="t">
@@ -18569,7 +18543,7 @@
                           <a:uFillTx/>
                           <a:latin typeface="Arial"/>
                         </a:rPr>
-                        <a:t>Local</a:t>
+                        <a:t>LM Studio local</a:t>
                       </a:r>
                       <a:endParaRPr lang="en-AU" sz="1800" b="0" u="none" strike="noStrike">
                         <a:solidFill>
@@ -18790,7 +18764,79 @@
                   </a:tcPr>
                 </a:tc>
               </a:tr>
-              <a:tr h="794160">
+              <a:tr h="547920">
+                <a:tc>
+                  <a:txBody>
+                    <a:bodyPr lIns="36000" rIns="36000" anchor="t">
+                      <a:noAutofit/>
+                    </a:bodyPr>
+                    <a:p>
+                      <a:pPr>
+                        <a:lnSpc>
+                          <a:spcPct val="100000"/>
+                        </a:lnSpc>
+                      </a:pPr>
+                      <a:r>
+                        <a:rPr lang="en-AU" sz="1800" b="0" u="none" strike="noStrike">
+                          <a:solidFill>
+                            <a:srgbClr val="000000"/>
+                          </a:solidFill>
+                          <a:effectLst/>
+                          <a:uFillTx/>
+                          <a:latin typeface="Arial"/>
+                          <a:ea typeface="Microsoft YaHei"/>
+                        </a:rPr>
+                        <a:t>Ollama c</a:t>
+                      </a:r>
+                      <a:r>
+                        <a:rPr lang="en-AU" sz="1800" b="0" u="none" strike="noStrike">
+                          <a:solidFill>
+                            <a:srgbClr val="000000"/>
+                          </a:solidFill>
+                          <a:effectLst/>
+                          <a:uFillTx/>
+                          <a:latin typeface="Arial"/>
+                        </a:rPr>
+                        <a:t>loud </a:t>
+                      </a:r>
+                      <a:endParaRPr lang="en-AU" sz="1800" b="0" u="none" strike="noStrike">
+                        <a:solidFill>
+                          <a:srgbClr val="000000"/>
+                        </a:solidFill>
+                        <a:effectLst/>
+                        <a:uFillTx/>
+                        <a:latin typeface="Arial"/>
+                      </a:endParaRPr>
+                    </a:p>
+                  </a:txBody>
+                  <a:tcPr anchor="t" marL="36000" marR="36000" marT="45720" marB="45720">
+                    <a:lnL w="7200">
+                      <a:solidFill>
+                        <a:srgbClr val="000000"/>
+                      </a:solidFill>
+                      <a:prstDash val="solid"/>
+                    </a:lnL>
+                    <a:lnR w="7200">
+                      <a:solidFill>
+                        <a:srgbClr val="000000"/>
+                      </a:solidFill>
+                      <a:prstDash val="solid"/>
+                    </a:lnR>
+                    <a:lnT w="7200">
+                      <a:solidFill>
+                        <a:srgbClr val="000000"/>
+                      </a:solidFill>
+                      <a:prstDash val="solid"/>
+                    </a:lnT>
+                    <a:lnB w="7200">
+                      <a:solidFill>
+                        <a:srgbClr val="000000"/>
+                      </a:solidFill>
+                      <a:prstDash val="solid"/>
+                    </a:lnB>
+                    <a:noFill/>
+                  </a:tcPr>
+                </a:tc>
                 <a:tc>
                   <a:txBody>
                     <a:bodyPr lIns="36000" rIns="36000" anchor="t">
@@ -18811,7 +18857,201 @@
                           <a:uFillTx/>
                           <a:latin typeface="Arial"/>
                         </a:rPr>
-                        <a:t>Cloud</a:t>
+                        <a:t>OpenAI</a:t>
+                      </a:r>
+                      <a:endParaRPr lang="en-AU" sz="1800" b="0" u="none" strike="noStrike">
+                        <a:solidFill>
+                          <a:srgbClr val="000000"/>
+                        </a:solidFill>
+                        <a:effectLst/>
+                        <a:uFillTx/>
+                        <a:latin typeface="Times New Roman"/>
+                      </a:endParaRPr>
+                    </a:p>
+                  </a:txBody>
+                  <a:tcPr anchor="t" marL="36000" marR="36000" marT="45720" marB="45720">
+                    <a:lnL w="7200">
+                      <a:solidFill>
+                        <a:srgbClr val="000000"/>
+                      </a:solidFill>
+                      <a:prstDash val="solid"/>
+                    </a:lnL>
+                    <a:lnR w="7200">
+                      <a:solidFill>
+                        <a:srgbClr val="000000"/>
+                      </a:solidFill>
+                      <a:prstDash val="solid"/>
+                    </a:lnR>
+                    <a:lnT w="7200">
+                      <a:solidFill>
+                        <a:srgbClr val="000000"/>
+                      </a:solidFill>
+                      <a:prstDash val="solid"/>
+                    </a:lnT>
+                    <a:lnB w="7200">
+                      <a:solidFill>
+                        <a:srgbClr val="000000"/>
+                      </a:solidFill>
+                      <a:prstDash val="solid"/>
+                    </a:lnB>
+                    <a:noFill/>
+                  </a:tcPr>
+                </a:tc>
+                <a:tc>
+                  <a:txBody>
+                    <a:bodyPr lIns="36000" rIns="36000" anchor="t">
+                      <a:noAutofit/>
+                    </a:bodyPr>
+                    <a:p>
+                      <a:pPr>
+                        <a:lnSpc>
+                          <a:spcPct val="100000"/>
+                        </a:lnSpc>
+                      </a:pPr>
+                      <a:r>
+                        <a:rPr lang="en-AU" sz="1800" b="0" u="none" strike="noStrike">
+                          <a:solidFill>
+                            <a:srgbClr val="000000"/>
+                          </a:solidFill>
+                          <a:effectLst/>
+                          <a:uFillTx/>
+                          <a:latin typeface="Arial"/>
+                        </a:rPr>
+                        <a:t>gpt-oss-120B</a:t>
+                      </a:r>
+                      <a:endParaRPr lang="en-AU" sz="1800" b="0" u="none" strike="noStrike">
+                        <a:solidFill>
+                          <a:srgbClr val="000000"/>
+                        </a:solidFill>
+                        <a:effectLst/>
+                        <a:uFillTx/>
+                        <a:latin typeface="Times New Roman"/>
+                      </a:endParaRPr>
+                    </a:p>
+                  </a:txBody>
+                  <a:tcPr anchor="t" marL="36000" marR="36000" marT="45720" marB="45720">
+                    <a:lnL w="7200">
+                      <a:solidFill>
+                        <a:srgbClr val="000000"/>
+                      </a:solidFill>
+                      <a:prstDash val="solid"/>
+                    </a:lnL>
+                    <a:lnR w="7200">
+                      <a:solidFill>
+                        <a:srgbClr val="000000"/>
+                      </a:solidFill>
+                      <a:prstDash val="solid"/>
+                    </a:lnR>
+                    <a:lnT w="7200">
+                      <a:solidFill>
+                        <a:srgbClr val="000000"/>
+                      </a:solidFill>
+                      <a:prstDash val="solid"/>
+                    </a:lnT>
+                    <a:lnB w="7200">
+                      <a:solidFill>
+                        <a:srgbClr val="000000"/>
+                      </a:solidFill>
+                      <a:prstDash val="solid"/>
+                    </a:lnB>
+                    <a:noFill/>
+                  </a:tcPr>
+                </a:tc>
+                <a:tc>
+                  <a:txBody>
+                    <a:bodyPr lIns="36000" rIns="36000" anchor="t">
+                      <a:noAutofit/>
+                    </a:bodyPr>
+                    <a:p>
+                      <a:pPr>
+                        <a:lnSpc>
+                          <a:spcPct val="100000"/>
+                        </a:lnSpc>
+                      </a:pPr>
+                      <a:r>
+                        <a:rPr lang="en-AU" sz="1800" b="0" u="none" strike="noStrike">
+                          <a:solidFill>
+                            <a:srgbClr val="000000"/>
+                          </a:solidFill>
+                          <a:effectLst/>
+                          <a:uFillTx/>
+                          <a:latin typeface="Arial"/>
+                        </a:rPr>
+                        <a:t>7.7 sec</a:t>
+                      </a:r>
+                      <a:endParaRPr lang="en-AU" sz="1800" b="0" u="none" strike="noStrike">
+                        <a:solidFill>
+                          <a:srgbClr val="000000"/>
+                        </a:solidFill>
+                        <a:effectLst/>
+                        <a:uFillTx/>
+                        <a:latin typeface="Times New Roman"/>
+                      </a:endParaRPr>
+                    </a:p>
+                  </a:txBody>
+                  <a:tcPr anchor="t" marL="36000" marR="36000" marT="45720" marB="45720">
+                    <a:lnL w="7200">
+                      <a:solidFill>
+                        <a:srgbClr val="000000"/>
+                      </a:solidFill>
+                      <a:prstDash val="solid"/>
+                    </a:lnL>
+                    <a:lnR w="7200">
+                      <a:solidFill>
+                        <a:srgbClr val="000000"/>
+                      </a:solidFill>
+                      <a:prstDash val="solid"/>
+                    </a:lnR>
+                    <a:lnT w="7200">
+                      <a:solidFill>
+                        <a:srgbClr val="000000"/>
+                      </a:solidFill>
+                      <a:prstDash val="solid"/>
+                    </a:lnT>
+                    <a:lnB w="7200">
+                      <a:solidFill>
+                        <a:srgbClr val="000000"/>
+                      </a:solidFill>
+                      <a:prstDash val="solid"/>
+                    </a:lnB>
+                    <a:noFill/>
+                  </a:tcPr>
+                </a:tc>
+              </a:tr>
+              <a:tr h="585720">
+                <a:tc>
+                  <a:txBody>
+                    <a:bodyPr lIns="36000" rIns="36000" anchor="t">
+                      <a:noAutofit/>
+                    </a:bodyPr>
+                    <a:p>
+                      <a:pPr>
+                        <a:lnSpc>
+                          <a:spcPct val="100000"/>
+                        </a:lnSpc>
+                      </a:pPr>
+                      <a:r>
+                        <a:rPr lang="en-AU" sz="1800" b="0" u="none" strike="noStrike">
+                          <a:solidFill>
+                            <a:srgbClr val="000000"/>
+                          </a:solidFill>
+                          <a:effectLst/>
+                          <a:uFillTx/>
+                          <a:latin typeface="Arial"/>
+                          <a:ea typeface="Microsoft YaHei"/>
+                        </a:rPr>
+                        <a:t>Ollama c</a:t>
+                      </a:r>
+                      <a:r>
+                        <a:rPr lang="en-AU" sz="1800" b="0" u="none" strike="noStrike">
+                          <a:solidFill>
+                            <a:srgbClr val="000000"/>
+                          </a:solidFill>
+                          <a:effectLst/>
+                          <a:uFillTx/>
+                          <a:latin typeface="Arial"/>
+                        </a:rPr>
+                        <a:t>loud </a:t>
                       </a:r>
                       <a:endParaRPr lang="en-AU" sz="1800" b="0" u="none" strike="noStrike">
                         <a:solidFill>
@@ -18931,6 +19171,255 @@
                           <a:uFillTx/>
                           <a:latin typeface="Arial"/>
                         </a:rPr>
+                        <a:t>Gemini 3 Flash</a:t>
+                      </a:r>
+                      <a:endParaRPr lang="en-AU" sz="1800" b="0" u="none" strike="noStrike">
+                        <a:solidFill>
+                          <a:srgbClr val="000000"/>
+                        </a:solidFill>
+                        <a:effectLst/>
+                        <a:uFillTx/>
+                        <a:latin typeface="Arial"/>
+                      </a:endParaRPr>
+                    </a:p>
+                  </a:txBody>
+                  <a:tcPr anchor="t" marL="36000" marR="36000" marT="45720" marB="45720">
+                    <a:lnL w="7200">
+                      <a:solidFill>
+                        <a:srgbClr val="000000"/>
+                      </a:solidFill>
+                      <a:prstDash val="solid"/>
+                    </a:lnL>
+                    <a:lnR w="7200">
+                      <a:solidFill>
+                        <a:srgbClr val="000000"/>
+                      </a:solidFill>
+                      <a:prstDash val="solid"/>
+                    </a:lnR>
+                    <a:lnT w="7200">
+                      <a:solidFill>
+                        <a:srgbClr val="000000"/>
+                      </a:solidFill>
+                      <a:prstDash val="solid"/>
+                    </a:lnT>
+                    <a:lnB w="7200">
+                      <a:solidFill>
+                        <a:srgbClr val="000000"/>
+                      </a:solidFill>
+                      <a:prstDash val="solid"/>
+                    </a:lnB>
+                    <a:noFill/>
+                  </a:tcPr>
+                </a:tc>
+                <a:tc>
+                  <a:txBody>
+                    <a:bodyPr lIns="36000" rIns="36000" anchor="t">
+                      <a:noAutofit/>
+                    </a:bodyPr>
+                    <a:p>
+                      <a:r>
+                        <a:rPr lang="en-AU" sz="1800" b="0" u="none" strike="noStrike">
+                          <a:solidFill>
+                            <a:srgbClr val="000000"/>
+                          </a:solidFill>
+                          <a:effectLst/>
+                          <a:uFillTx/>
+                          <a:latin typeface="Arial"/>
+                        </a:rPr>
+                        <a:t>22.9 sec</a:t>
+                      </a:r>
+                      <a:endParaRPr lang="en-AU" sz="1800" b="0" u="none" strike="noStrike">
+                        <a:solidFill>
+                          <a:srgbClr val="000000"/>
+                        </a:solidFill>
+                        <a:effectLst/>
+                        <a:uFillTx/>
+                        <a:latin typeface="Arial"/>
+                      </a:endParaRPr>
+                    </a:p>
+                  </a:txBody>
+                  <a:tcPr anchor="t" marL="36000" marR="36000" marT="45720" marB="45720">
+                    <a:lnL w="7200">
+                      <a:solidFill>
+                        <a:srgbClr val="000000"/>
+                      </a:solidFill>
+                      <a:prstDash val="solid"/>
+                    </a:lnL>
+                    <a:lnR w="7200">
+                      <a:solidFill>
+                        <a:srgbClr val="000000"/>
+                      </a:solidFill>
+                      <a:prstDash val="solid"/>
+                    </a:lnR>
+                    <a:lnT w="7200">
+                      <a:solidFill>
+                        <a:srgbClr val="000000"/>
+                      </a:solidFill>
+                      <a:prstDash val="solid"/>
+                    </a:lnT>
+                    <a:lnB w="7200">
+                      <a:solidFill>
+                        <a:srgbClr val="000000"/>
+                      </a:solidFill>
+                      <a:prstDash val="solid"/>
+                    </a:lnB>
+                    <a:noFill/>
+                  </a:tcPr>
+                </a:tc>
+              </a:tr>
+              <a:tr h="610920">
+                <a:tc>
+                  <a:txBody>
+                    <a:bodyPr lIns="36000" rIns="36000" anchor="t">
+                      <a:noAutofit/>
+                    </a:bodyPr>
+                    <a:p>
+                      <a:pPr>
+                        <a:lnSpc>
+                          <a:spcPct val="100000"/>
+                        </a:lnSpc>
+                      </a:pPr>
+                      <a:r>
+                        <a:rPr lang="en-AU" sz="1800" b="0" u="none" strike="noStrike">
+                          <a:solidFill>
+                            <a:srgbClr val="000000"/>
+                          </a:solidFill>
+                          <a:effectLst/>
+                          <a:uFillTx/>
+                          <a:latin typeface="Arial"/>
+                          <a:ea typeface="Microsoft YaHei"/>
+                        </a:rPr>
+                        <a:t>Google c</a:t>
+                      </a:r>
+                      <a:r>
+                        <a:rPr lang="en-AU" sz="1800" b="0" u="none" strike="noStrike">
+                          <a:solidFill>
+                            <a:srgbClr val="000000"/>
+                          </a:solidFill>
+                          <a:effectLst/>
+                          <a:uFillTx/>
+                          <a:latin typeface="Arial"/>
+                        </a:rPr>
+                        <a:t>loud </a:t>
+                      </a:r>
+                      <a:endParaRPr lang="en-AU" sz="1800" b="0" u="none" strike="noStrike">
+                        <a:solidFill>
+                          <a:srgbClr val="000000"/>
+                        </a:solidFill>
+                        <a:effectLst/>
+                        <a:uFillTx/>
+                        <a:latin typeface="Arial"/>
+                      </a:endParaRPr>
+                    </a:p>
+                  </a:txBody>
+                  <a:tcPr anchor="t" marL="36000" marR="36000" marT="45720" marB="45720">
+                    <a:lnL w="7200">
+                      <a:solidFill>
+                        <a:srgbClr val="000000"/>
+                      </a:solidFill>
+                      <a:prstDash val="solid"/>
+                    </a:lnL>
+                    <a:lnR w="7200">
+                      <a:solidFill>
+                        <a:srgbClr val="000000"/>
+                      </a:solidFill>
+                      <a:prstDash val="solid"/>
+                    </a:lnR>
+                    <a:lnT w="7200">
+                      <a:solidFill>
+                        <a:srgbClr val="000000"/>
+                      </a:solidFill>
+                      <a:prstDash val="solid"/>
+                    </a:lnT>
+                    <a:lnB w="7200">
+                      <a:solidFill>
+                        <a:srgbClr val="000000"/>
+                      </a:solidFill>
+                      <a:prstDash val="solid"/>
+                    </a:lnB>
+                    <a:noFill/>
+                  </a:tcPr>
+                </a:tc>
+                <a:tc>
+                  <a:txBody>
+                    <a:bodyPr lIns="36000" rIns="36000" anchor="t">
+                      <a:noAutofit/>
+                    </a:bodyPr>
+                    <a:p>
+                      <a:pPr>
+                        <a:lnSpc>
+                          <a:spcPct val="100000"/>
+                        </a:lnSpc>
+                      </a:pPr>
+                      <a:r>
+                        <a:rPr lang="en-AU" sz="1800" b="0" u="none" strike="noStrike">
+                          <a:solidFill>
+                            <a:srgbClr val="000000"/>
+                          </a:solidFill>
+                          <a:effectLst/>
+                          <a:uFillTx/>
+                          <a:latin typeface="Arial"/>
+                        </a:rPr>
+                        <a:t>Google</a:t>
+                      </a:r>
+                      <a:endParaRPr lang="en-AU" sz="1800" b="0" u="none" strike="noStrike">
+                        <a:solidFill>
+                          <a:srgbClr val="000000"/>
+                        </a:solidFill>
+                        <a:effectLst/>
+                        <a:uFillTx/>
+                        <a:latin typeface="Arial"/>
+                      </a:endParaRPr>
+                    </a:p>
+                  </a:txBody>
+                  <a:tcPr anchor="t" marL="36000" marR="36000" marT="45720" marB="45720">
+                    <a:lnL w="7200">
+                      <a:solidFill>
+                        <a:srgbClr val="000000"/>
+                      </a:solidFill>
+                      <a:prstDash val="solid"/>
+                    </a:lnL>
+                    <a:lnR w="7200">
+                      <a:solidFill>
+                        <a:srgbClr val="000000"/>
+                      </a:solidFill>
+                      <a:prstDash val="solid"/>
+                    </a:lnR>
+                    <a:lnT w="7200">
+                      <a:solidFill>
+                        <a:srgbClr val="000000"/>
+                      </a:solidFill>
+                      <a:prstDash val="solid"/>
+                    </a:lnT>
+                    <a:lnB w="7200">
+                      <a:solidFill>
+                        <a:srgbClr val="000000"/>
+                      </a:solidFill>
+                      <a:prstDash val="solid"/>
+                    </a:lnB>
+                    <a:noFill/>
+                  </a:tcPr>
+                </a:tc>
+                <a:tc>
+                  <a:txBody>
+                    <a:bodyPr lIns="36000" rIns="36000" anchor="t">
+                      <a:noAutofit/>
+                    </a:bodyPr>
+                    <a:p>
+                      <a:pPr>
+                        <a:lnSpc>
+                          <a:spcPct val="100000"/>
+                        </a:lnSpc>
+                      </a:pPr>
+                      <a:r>
+                        <a:rPr lang="en-AU" sz="1800" b="0" u="none" strike="noStrike">
+                          <a:solidFill>
+                            <a:srgbClr val="000000"/>
+                          </a:solidFill>
+                          <a:effectLst/>
+                          <a:uFillTx/>
+                          <a:latin typeface="Arial"/>
+                        </a:rPr>
                         <a:t>Gemini 3.1</a:t>
                       </a:r>
                       <a:endParaRPr lang="en-AU" sz="1800" b="0" u="none" strike="noStrike">
@@ -19050,7 +19539,7 @@
         <p:txBody>
           <a:bodyPr/>
           <a:p>
-            <a:fld id="{EE7E1A66-D7B9-4129-98D9-A289B3D9F325}" type="slidenum">
+            <a:fld id="{7B498ECB-7721-4FB1-8092-43359122039A}" type="slidenum">
               <a:t>20</a:t>
             </a:fld>
           </a:p>
@@ -19098,8 +19587,8 @@
         </p:nvSpPr>
         <p:spPr>
           <a:xfrm>
-            <a:off x="0" y="1615320"/>
-            <a:ext cx="8995320" cy="1084680"/>
+            <a:off x="0" y="1614960"/>
+            <a:ext cx="8994960" cy="1085040"/>
           </a:xfrm>
           <a:prstGeom prst="rect">
             <a:avLst/>
@@ -19187,8 +19676,8 @@
         </p:nvSpPr>
         <p:spPr>
           <a:xfrm>
-            <a:off x="360000" y="163440"/>
-            <a:ext cx="9355320" cy="506520"/>
+            <a:off x="360000" y="163080"/>
+            <a:ext cx="9354960" cy="506880"/>
           </a:xfrm>
           <a:prstGeom prst="rect">
             <a:avLst/>
@@ -19247,7 +19736,7 @@
         <p:spPr>
           <a:xfrm>
             <a:off x="628200" y="973800"/>
-            <a:ext cx="8844840" cy="3729240"/>
+            <a:ext cx="8844480" cy="3728880"/>
           </a:xfrm>
           <a:prstGeom prst="rect">
             <a:avLst/>
@@ -19272,7 +19761,7 @@
         <p:txBody>
           <a:bodyPr/>
           <a:p>
-            <a:fld id="{00FB5E5B-4A33-413D-9CFF-CE71F6D00688}" type="slidenum">
+            <a:fld id="{307B7280-9328-4F4C-98BA-207E63BCA9CC}" type="slidenum">
               <a:t>22</a:t>
             </a:fld>
           </a:p>
@@ -19320,8 +19809,8 @@
         </p:nvSpPr>
         <p:spPr>
           <a:xfrm>
-            <a:off x="360000" y="163440"/>
-            <a:ext cx="9355320" cy="506520"/>
+            <a:off x="360000" y="163080"/>
+            <a:ext cx="9354960" cy="506880"/>
           </a:xfrm>
           <a:prstGeom prst="rect">
             <a:avLst/>
@@ -19380,7 +19869,7 @@
         <p:spPr>
           <a:xfrm>
             <a:off x="39600" y="871920"/>
-            <a:ext cx="10077120" cy="3952440"/>
+            <a:ext cx="10076760" cy="3952080"/>
           </a:xfrm>
           <a:prstGeom prst="rect">
             <a:avLst/>
@@ -19405,7 +19894,7 @@
         <p:txBody>
           <a:bodyPr/>
           <a:p>
-            <a:fld id="{6F5EC07C-615F-460F-8598-DE4D54B33E13}" type="slidenum">
+            <a:fld id="{B36ECF23-598F-43B0-A07B-6C7A37EF77DD}" type="slidenum">
               <a:t>23</a:t>
             </a:fld>
           </a:p>
@@ -19453,8 +19942,8 @@
         </p:nvSpPr>
         <p:spPr>
           <a:xfrm>
-            <a:off x="360000" y="163440"/>
-            <a:ext cx="9355320" cy="506880"/>
+            <a:off x="360000" y="163080"/>
+            <a:ext cx="9354960" cy="507240"/>
           </a:xfrm>
           <a:prstGeom prst="rect">
             <a:avLst/>
@@ -19513,7 +20002,7 @@
         <p:spPr>
           <a:xfrm>
             <a:off x="1186920" y="1283400"/>
-            <a:ext cx="7693200" cy="3092040"/>
+            <a:ext cx="7692840" cy="3091680"/>
           </a:xfrm>
           <a:prstGeom prst="rect">
             <a:avLst/>
@@ -19538,7 +20027,7 @@
         <p:txBody>
           <a:bodyPr/>
           <a:p>
-            <a:fld id="{94F617AA-ED0D-4E40-9E1D-01BB5F695A0E}" type="slidenum">
+            <a:fld id="{D55FE51A-F28C-42E5-97B4-843256ADB6EB}" type="slidenum">
               <a:t>24</a:t>
             </a:fld>
           </a:p>
@@ -19586,8 +20075,8 @@
         </p:nvSpPr>
         <p:spPr>
           <a:xfrm>
-            <a:off x="0" y="1615680"/>
-            <a:ext cx="8995680" cy="1084320"/>
+            <a:off x="0" y="1615320"/>
+            <a:ext cx="8995320" cy="1084680"/>
           </a:xfrm>
           <a:prstGeom prst="rect">
             <a:avLst/>
@@ -19675,8 +20164,8 @@
         </p:nvSpPr>
         <p:spPr>
           <a:xfrm>
-            <a:off x="360000" y="163800"/>
-            <a:ext cx="9355680" cy="506520"/>
+            <a:off x="360000" y="163440"/>
+            <a:ext cx="9355320" cy="506880"/>
           </a:xfrm>
           <a:prstGeom prst="rect">
             <a:avLst/>
@@ -19735,7 +20224,7 @@
         <p:spPr>
           <a:xfrm>
             <a:off x="1653480" y="1407240"/>
-            <a:ext cx="6759720" cy="2844360"/>
+            <a:ext cx="6759360" cy="2844000"/>
           </a:xfrm>
           <a:prstGeom prst="rect">
             <a:avLst/>
@@ -19760,7 +20249,7 @@
         <p:txBody>
           <a:bodyPr/>
           <a:p>
-            <a:fld id="{2184514F-5D90-45D9-A268-318BB4CCE602}" type="slidenum">
+            <a:fld id="{F94334C6-40FD-4448-9398-FBA0E677058D}" type="slidenum">
               <a:t>26</a:t>
             </a:fld>
           </a:p>
@@ -19808,8 +20297,8 @@
         </p:nvSpPr>
         <p:spPr>
           <a:xfrm>
-            <a:off x="360000" y="163800"/>
-            <a:ext cx="9355680" cy="506520"/>
+            <a:off x="360000" y="163440"/>
+            <a:ext cx="9355320" cy="506880"/>
           </a:xfrm>
           <a:prstGeom prst="rect">
             <a:avLst/>
@@ -19868,7 +20357,7 @@
         <p:spPr>
           <a:xfrm>
             <a:off x="39600" y="1434600"/>
-            <a:ext cx="10077120" cy="4524840"/>
+            <a:ext cx="10076760" cy="4524480"/>
           </a:xfrm>
           <a:prstGeom prst="rect">
             <a:avLst/>
@@ -19893,7 +20382,7 @@
         <p:txBody>
           <a:bodyPr/>
           <a:p>
-            <a:fld id="{9BCA44EB-7F0D-4E91-BD5B-2B19BE3FFC65}" type="slidenum">
+            <a:fld id="{A4EE083B-D6D5-4357-9BB0-4A2E8C9D621C}" type="slidenum">
               <a:t>27</a:t>
             </a:fld>
           </a:p>
@@ -19941,8 +20430,8 @@
         </p:nvSpPr>
         <p:spPr>
           <a:xfrm>
-            <a:off x="360000" y="163800"/>
-            <a:ext cx="9355680" cy="506520"/>
+            <a:off x="360000" y="163440"/>
+            <a:ext cx="9355320" cy="506880"/>
           </a:xfrm>
           <a:prstGeom prst="rect">
             <a:avLst/>
@@ -20001,7 +20490,7 @@
         <p:spPr>
           <a:xfrm>
             <a:off x="39600" y="1571760"/>
-            <a:ext cx="10077120" cy="2552400"/>
+            <a:ext cx="10076760" cy="2552040"/>
           </a:xfrm>
           <a:prstGeom prst="rect">
             <a:avLst/>
@@ -20026,7 +20515,7 @@
         <p:txBody>
           <a:bodyPr/>
           <a:p>
-            <a:fld id="{B06F77AE-D42B-4A90-B48B-BE712F8D704B}" type="slidenum">
+            <a:fld id="{6125FC16-846B-42E0-8B00-4C31FA44132B}" type="slidenum">
               <a:t>28</a:t>
             </a:fld>
           </a:p>
@@ -20074,8 +20563,8 @@
         </p:nvSpPr>
         <p:spPr>
           <a:xfrm>
-            <a:off x="360000" y="163800"/>
-            <a:ext cx="9355680" cy="506520"/>
+            <a:off x="360000" y="163440"/>
+            <a:ext cx="9355320" cy="506880"/>
           </a:xfrm>
           <a:prstGeom prst="rect">
             <a:avLst/>
@@ -20134,7 +20623,7 @@
         <p:spPr>
           <a:xfrm>
             <a:off x="39600" y="1403640"/>
-            <a:ext cx="10077120" cy="3743280"/>
+            <a:ext cx="10076760" cy="3742920"/>
           </a:xfrm>
           <a:prstGeom prst="rect">
             <a:avLst/>
@@ -20159,7 +20648,7 @@
         <p:txBody>
           <a:bodyPr/>
           <a:p>
-            <a:fld id="{C5686D45-CE24-4FC3-A348-419E719274A7}" type="slidenum">
+            <a:fld id="{27FF79A4-59C4-435C-8236-7537B36E5B4D}" type="slidenum">
               <a:t>29</a:t>
             </a:fld>
           </a:p>
@@ -20207,8 +20696,8 @@
         </p:nvSpPr>
         <p:spPr>
           <a:xfrm>
-            <a:off x="360000" y="162720"/>
-            <a:ext cx="9354600" cy="507240"/>
+            <a:off x="360000" y="162360"/>
+            <a:ext cx="9354240" cy="507600"/>
           </a:xfrm>
           <a:prstGeom prst="rect">
             <a:avLst/>
@@ -20267,7 +20756,7 @@
         <p:spPr>
           <a:xfrm>
             <a:off x="2311920" y="995400"/>
-            <a:ext cx="5465520" cy="3693600"/>
+            <a:ext cx="5465160" cy="3693240"/>
           </a:xfrm>
           <a:prstGeom prst="rect">
             <a:avLst/>
@@ -20292,7 +20781,7 @@
         <p:txBody>
           <a:bodyPr/>
           <a:p>
-            <a:fld id="{4B6155F3-9123-4E01-BD37-89CCA087BA2D}" type="slidenum">
+            <a:fld id="{7CFE94F8-F004-4074-A97B-E5112C89377B}" type="slidenum">
               <a:t>3</a:t>
             </a:fld>
           </a:p>
@@ -20340,8 +20829,8 @@
         </p:nvSpPr>
         <p:spPr>
           <a:xfrm>
-            <a:off x="360000" y="163800"/>
-            <a:ext cx="9355680" cy="506520"/>
+            <a:off x="360000" y="163440"/>
+            <a:ext cx="9355320" cy="506880"/>
           </a:xfrm>
           <a:prstGeom prst="rect">
             <a:avLst/>
@@ -20396,7 +20885,7 @@
         <p:spPr>
           <a:xfrm>
             <a:off x="315720" y="878040"/>
-            <a:ext cx="9527400" cy="3885120"/>
+            <a:ext cx="9527040" cy="3884760"/>
           </a:xfrm>
           <a:prstGeom prst="rect">
             <a:avLst/>
@@ -20678,7 +21167,7 @@
         <p:txBody>
           <a:bodyPr/>
           <a:p>
-            <a:fld id="{74BB6049-D137-4F7E-AD66-7CD0B0D3BED0}" type="slidenum">
+            <a:fld id="{F15EF80B-7FA2-4BE3-9462-D4BF23C84A0C}" type="slidenum">
               <a:t>30</a:t>
             </a:fld>
           </a:p>
@@ -20726,8 +21215,8 @@
         </p:nvSpPr>
         <p:spPr>
           <a:xfrm>
-            <a:off x="360000" y="162720"/>
-            <a:ext cx="9354600" cy="507240"/>
+            <a:off x="360000" y="162360"/>
+            <a:ext cx="9354240" cy="507600"/>
           </a:xfrm>
           <a:prstGeom prst="rect">
             <a:avLst/>
@@ -20786,7 +21275,7 @@
         <p:spPr>
           <a:xfrm>
             <a:off x="360000" y="1080000"/>
-            <a:ext cx="9354600" cy="3594600"/>
+            <a:ext cx="9354240" cy="3594240"/>
           </a:xfrm>
           <a:prstGeom prst="rect">
             <a:avLst/>
@@ -20923,7 +21412,7 @@
         <p:txBody>
           <a:bodyPr/>
           <a:p>
-            <a:fld id="{203CF68D-5622-4A26-B512-785A169F91D5}" type="slidenum">
+            <a:fld id="{6E13A2EC-A713-49C2-9E67-10F67732F7A0}" type="slidenum">
               <a:t>4</a:t>
             </a:fld>
           </a:p>
@@ -20971,8 +21460,8 @@
         </p:nvSpPr>
         <p:spPr>
           <a:xfrm>
-            <a:off x="360000" y="162720"/>
-            <a:ext cx="9354600" cy="507240"/>
+            <a:off x="360000" y="162360"/>
+            <a:ext cx="9354240" cy="507600"/>
           </a:xfrm>
           <a:prstGeom prst="rect">
             <a:avLst/>
@@ -21031,7 +21520,7 @@
         <p:spPr>
           <a:xfrm>
             <a:off x="360000" y="1080000"/>
-            <a:ext cx="9354600" cy="3594600"/>
+            <a:ext cx="9354240" cy="3594240"/>
           </a:xfrm>
           <a:prstGeom prst="rect">
             <a:avLst/>
@@ -21203,7 +21692,7 @@
         <p:txBody>
           <a:bodyPr/>
           <a:p>
-            <a:fld id="{69E8C1CD-F5FE-48F8-8530-5CFFFC2925E1}" type="slidenum">
+            <a:fld id="{F29DD893-83EF-4F13-8BE9-7146038A9629}" type="slidenum">
               <a:t>5</a:t>
             </a:fld>
           </a:p>
@@ -21251,8 +21740,8 @@
         </p:nvSpPr>
         <p:spPr>
           <a:xfrm>
-            <a:off x="360000" y="162720"/>
-            <a:ext cx="9354600" cy="507240"/>
+            <a:off x="360000" y="162360"/>
+            <a:ext cx="9354240" cy="507600"/>
           </a:xfrm>
           <a:prstGeom prst="rect">
             <a:avLst/>
@@ -21311,7 +21800,7 @@
         <p:spPr>
           <a:xfrm>
             <a:off x="360000" y="1080000"/>
-            <a:ext cx="9354600" cy="3594600"/>
+            <a:ext cx="9354240" cy="3594240"/>
           </a:xfrm>
           <a:prstGeom prst="rect">
             <a:avLst/>
@@ -21586,7 +22075,7 @@
         <p:txBody>
           <a:bodyPr/>
           <a:p>
-            <a:fld id="{22602AF0-B2DC-456A-A34B-BE5BAE949EC7}" type="slidenum">
+            <a:fld id="{8C8A3475-D324-4817-9AB4-12C244AD857A}" type="slidenum">
               <a:t>6</a:t>
             </a:fld>
           </a:p>
@@ -21634,8 +22123,8 @@
         </p:nvSpPr>
         <p:spPr>
           <a:xfrm>
-            <a:off x="360000" y="162720"/>
-            <a:ext cx="9354600" cy="507240"/>
+            <a:off x="360000" y="162360"/>
+            <a:ext cx="9354240" cy="507600"/>
           </a:xfrm>
           <a:prstGeom prst="rect">
             <a:avLst/>
@@ -21694,7 +22183,7 @@
         <p:spPr>
           <a:xfrm>
             <a:off x="360000" y="1080000"/>
-            <a:ext cx="9354600" cy="3594600"/>
+            <a:ext cx="9354240" cy="3594240"/>
           </a:xfrm>
           <a:prstGeom prst="rect">
             <a:avLst/>
@@ -21934,7 +22423,7 @@
         <p:txBody>
           <a:bodyPr/>
           <a:p>
-            <a:fld id="{6748A8E0-B5C1-4DEE-9BE6-E1AF4361D9D3}" type="slidenum">
+            <a:fld id="{3A8E6BA0-7CF5-416C-87E2-F5ADA3EC1366}" type="slidenum">
               <a:t>7</a:t>
             </a:fld>
           </a:p>
@@ -21982,8 +22471,8 @@
         </p:nvSpPr>
         <p:spPr>
           <a:xfrm>
-            <a:off x="360000" y="162720"/>
-            <a:ext cx="9354600" cy="507240"/>
+            <a:off x="360000" y="162360"/>
+            <a:ext cx="9354240" cy="507600"/>
           </a:xfrm>
           <a:prstGeom prst="rect">
             <a:avLst/>
@@ -22042,7 +22531,7 @@
         <p:spPr>
           <a:xfrm>
             <a:off x="360000" y="1080000"/>
-            <a:ext cx="9354600" cy="3594600"/>
+            <a:ext cx="9354240" cy="3594240"/>
           </a:xfrm>
           <a:prstGeom prst="rect">
             <a:avLst/>
@@ -22256,7 +22745,7 @@
         <p:txBody>
           <a:bodyPr/>
           <a:p>
-            <a:fld id="{5679E938-8523-4F38-85EC-EA9F0C452303}" type="slidenum">
+            <a:fld id="{AE941DB7-846C-45C9-A73E-BDA973486803}" type="slidenum">
               <a:t>8</a:t>
             </a:fld>
           </a:p>
@@ -22304,8 +22793,8 @@
         </p:nvSpPr>
         <p:spPr>
           <a:xfrm>
-            <a:off x="360000" y="162720"/>
-            <a:ext cx="9354600" cy="507240"/>
+            <a:off x="360000" y="162360"/>
+            <a:ext cx="9354240" cy="507600"/>
           </a:xfrm>
           <a:prstGeom prst="rect">
             <a:avLst/>
@@ -22364,7 +22853,7 @@
         <p:spPr>
           <a:xfrm>
             <a:off x="360000" y="1080000"/>
-            <a:ext cx="9354600" cy="3594600"/>
+            <a:ext cx="9354240" cy="3594240"/>
           </a:xfrm>
           <a:prstGeom prst="rect">
             <a:avLst/>
@@ -22613,7 +23102,7 @@
         <p:txBody>
           <a:bodyPr/>
           <a:p>
-            <a:fld id="{FBBDBDCE-2827-4607-ADEA-B96708D7F50B}" type="slidenum">
+            <a:fld id="{F9F69592-1777-4CF9-B428-2205924B16D8}" type="slidenum">
               <a:t>9</a:t>
             </a:fld>
           </a:p>

</xml_diff>